<commit_message>
Remove axis.line/axis.ticks linewidth=0.8 override; unify all figures to theme_Publication's default
Per user request: rather than matching Fig.3/4/5 up to common_style's 0.8
linewidth (as done in the previous commit), remove the override entirely
so every figure - including Fig.1/2/S1/S2/S3, which previously had it via
common_style - inherits the same unset default from theme_Publication()
alone. True single source of truth for axis line/tick thickness now.
</commit_message>
<xml_diff>
--- a/figures/Figure_5.pptx
+++ b/figures/Figure_5.pptx
@@ -4755,7 +4755,7 @@
                 </a:path>
               </a:pathLst>
             </a:custGeom>
-            <a:ln w="21681" cap="flat">
+            <a:ln w="11086" cap="flat">
               <a:solidFill>
                 <a:srgbClr val="000000">
                   <a:alpha val="100000"/>
@@ -5485,9 +5485,9 @@
                 </a:path>
               </a:pathLst>
             </a:custGeom>
-            <a:ln w="21681" cap="flat">
-              <a:solidFill>
-                <a:srgbClr val="000000">
+            <a:ln w="11086" cap="flat">
+              <a:solidFill>
+                <a:srgbClr val="333333">
                   <a:alpha val="100000"/>
                 </a:srgbClr>
               </a:solidFill>
@@ -5525,9 +5525,9 @@
                 </a:path>
               </a:pathLst>
             </a:custGeom>
-            <a:ln w="21681" cap="flat">
-              <a:solidFill>
-                <a:srgbClr val="000000">
+            <a:ln w="11086" cap="flat">
+              <a:solidFill>
+                <a:srgbClr val="333333">
                   <a:alpha val="100000"/>
                 </a:srgbClr>
               </a:solidFill>
@@ -5565,9 +5565,9 @@
                 </a:path>
               </a:pathLst>
             </a:custGeom>
-            <a:ln w="21681" cap="flat">
-              <a:solidFill>
-                <a:srgbClr val="000000">
+            <a:ln w="11086" cap="flat">
+              <a:solidFill>
+                <a:srgbClr val="333333">
                   <a:alpha val="100000"/>
                 </a:srgbClr>
               </a:solidFill>
@@ -5605,9 +5605,9 @@
                 </a:path>
               </a:pathLst>
             </a:custGeom>
-            <a:ln w="21681" cap="flat">
-              <a:solidFill>
-                <a:srgbClr val="000000">
+            <a:ln w="11086" cap="flat">
+              <a:solidFill>
+                <a:srgbClr val="333333">
                   <a:alpha val="100000"/>
                 </a:srgbClr>
               </a:solidFill>
@@ -5645,9 +5645,9 @@
                 </a:path>
               </a:pathLst>
             </a:custGeom>
-            <a:ln w="21681" cap="flat">
-              <a:solidFill>
-                <a:srgbClr val="000000">
+            <a:ln w="11086" cap="flat">
+              <a:solidFill>
+                <a:srgbClr val="333333">
                   <a:alpha val="100000"/>
                 </a:srgbClr>
               </a:solidFill>
@@ -5685,9 +5685,9 @@
                 </a:path>
               </a:pathLst>
             </a:custGeom>
-            <a:ln w="21681" cap="flat">
-              <a:solidFill>
-                <a:srgbClr val="000000">
+            <a:ln w="11086" cap="flat">
+              <a:solidFill>
+                <a:srgbClr val="333333">
                   <a:alpha val="100000"/>
                 </a:srgbClr>
               </a:solidFill>
@@ -5725,9 +5725,9 @@
                 </a:path>
               </a:pathLst>
             </a:custGeom>
-            <a:ln w="21681" cap="flat">
-              <a:solidFill>
-                <a:srgbClr val="000000">
+            <a:ln w="11086" cap="flat">
+              <a:solidFill>
+                <a:srgbClr val="333333">
                   <a:alpha val="100000"/>
                 </a:srgbClr>
               </a:solidFill>
@@ -5765,9 +5765,9 @@
                 </a:path>
               </a:pathLst>
             </a:custGeom>
-            <a:ln w="21681" cap="flat">
-              <a:solidFill>
-                <a:srgbClr val="000000">
+            <a:ln w="11086" cap="flat">
+              <a:solidFill>
+                <a:srgbClr val="333333">
                   <a:alpha val="100000"/>
                 </a:srgbClr>
               </a:solidFill>
@@ -5805,9 +5805,9 @@
                 </a:path>
               </a:pathLst>
             </a:custGeom>
-            <a:ln w="21681" cap="flat">
-              <a:solidFill>
-                <a:srgbClr val="000000">
+            <a:ln w="11086" cap="flat">
+              <a:solidFill>
+                <a:srgbClr val="333333">
                   <a:alpha val="100000"/>
                 </a:srgbClr>
               </a:solidFill>
@@ -5845,9 +5845,9 @@
                 </a:path>
               </a:pathLst>
             </a:custGeom>
-            <a:ln w="21681" cap="flat">
-              <a:solidFill>
-                <a:srgbClr val="000000">
+            <a:ln w="11086" cap="flat">
+              <a:solidFill>
+                <a:srgbClr val="333333">
                   <a:alpha val="100000"/>
                 </a:srgbClr>
               </a:solidFill>
@@ -5885,9 +5885,9 @@
                 </a:path>
               </a:pathLst>
             </a:custGeom>
-            <a:ln w="21681" cap="flat">
-              <a:solidFill>
-                <a:srgbClr val="000000">
+            <a:ln w="11086" cap="flat">
+              <a:solidFill>
+                <a:srgbClr val="333333">
                   <a:alpha val="100000"/>
                 </a:srgbClr>
               </a:solidFill>
@@ -5925,9 +5925,9 @@
                 </a:path>
               </a:pathLst>
             </a:custGeom>
-            <a:ln w="21681" cap="flat">
-              <a:solidFill>
-                <a:srgbClr val="000000">
+            <a:ln w="11086" cap="flat">
+              <a:solidFill>
+                <a:srgbClr val="333333">
                   <a:alpha val="100000"/>
                 </a:srgbClr>
               </a:solidFill>
@@ -5965,9 +5965,9 @@
                 </a:path>
               </a:pathLst>
             </a:custGeom>
-            <a:ln w="21681" cap="flat">
-              <a:solidFill>
-                <a:srgbClr val="000000">
+            <a:ln w="11086" cap="flat">
+              <a:solidFill>
+                <a:srgbClr val="333333">
                   <a:alpha val="100000"/>
                 </a:srgbClr>
               </a:solidFill>
@@ -6005,9 +6005,9 @@
                 </a:path>
               </a:pathLst>
             </a:custGeom>
-            <a:ln w="21681" cap="flat">
-              <a:solidFill>
-                <a:srgbClr val="000000">
+            <a:ln w="11086" cap="flat">
+              <a:solidFill>
+                <a:srgbClr val="333333">
                   <a:alpha val="100000"/>
                 </a:srgbClr>
               </a:solidFill>
@@ -6045,9 +6045,9 @@
                 </a:path>
               </a:pathLst>
             </a:custGeom>
-            <a:ln w="21681" cap="flat">
-              <a:solidFill>
-                <a:srgbClr val="000000">
+            <a:ln w="11086" cap="flat">
+              <a:solidFill>
+                <a:srgbClr val="333333">
                   <a:alpha val="100000"/>
                 </a:srgbClr>
               </a:solidFill>
@@ -6085,7 +6085,7 @@
                 </a:path>
               </a:pathLst>
             </a:custGeom>
-            <a:ln w="21681" cap="flat">
+            <a:ln w="11086" cap="flat">
               <a:solidFill>
                 <a:srgbClr val="000000">
                   <a:alpha val="100000"/>
@@ -6125,9 +6125,9 @@
                 </a:path>
               </a:pathLst>
             </a:custGeom>
-            <a:ln w="21681" cap="flat">
-              <a:solidFill>
-                <a:srgbClr val="000000">
+            <a:ln w="11086" cap="flat">
+              <a:solidFill>
+                <a:srgbClr val="333333">
                   <a:alpha val="100000"/>
                 </a:srgbClr>
               </a:solidFill>
@@ -6165,9 +6165,9 @@
                 </a:path>
               </a:pathLst>
             </a:custGeom>
-            <a:ln w="21681" cap="flat">
-              <a:solidFill>
-                <a:srgbClr val="000000">
+            <a:ln w="11086" cap="flat">
+              <a:solidFill>
+                <a:srgbClr val="333333">
                   <a:alpha val="100000"/>
                 </a:srgbClr>
               </a:solidFill>
@@ -6205,9 +6205,9 @@
                 </a:path>
               </a:pathLst>
             </a:custGeom>
-            <a:ln w="21681" cap="flat">
-              <a:solidFill>
-                <a:srgbClr val="000000">
+            <a:ln w="11086" cap="flat">
+              <a:solidFill>
+                <a:srgbClr val="333333">
                   <a:alpha val="100000"/>
                 </a:srgbClr>
               </a:solidFill>
@@ -6245,9 +6245,9 @@
                 </a:path>
               </a:pathLst>
             </a:custGeom>
-            <a:ln w="21681" cap="flat">
-              <a:solidFill>
-                <a:srgbClr val="000000">
+            <a:ln w="11086" cap="flat">
+              <a:solidFill>
+                <a:srgbClr val="333333">
                   <a:alpha val="100000"/>
                 </a:srgbClr>
               </a:solidFill>
@@ -6285,9 +6285,9 @@
                 </a:path>
               </a:pathLst>
             </a:custGeom>
-            <a:ln w="21681" cap="flat">
-              <a:solidFill>
-                <a:srgbClr val="000000">
+            <a:ln w="11086" cap="flat">
+              <a:solidFill>
+                <a:srgbClr val="333333">
                   <a:alpha val="100000"/>
                 </a:srgbClr>
               </a:solidFill>

</xml_diff>

<commit_message>
Increase all figure text sizes by one point across the board
base_size 9->10, axis.title 10->11, axis.text 8->9, legend.title 9->10,
legend.text 8->9, plot.title/tag 10->11, in-panel Slope/p annotations
9pt->10pt, and the PCA biplot trait-axis labels 4mm->4.5mm. Applies
uniformly to theme_Publication, common_style (Fig.1/2/S1/S2/S3), and the
Fig.3/4/5 panel builders so the whole figure set stays consistent.
</commit_message>
<xml_diff>
--- a/figures/Figure_5.pptx
+++ b/figures/Figure_5.pptx
@@ -2324,8 +2324,8 @@
           </p:nvSpPr>
           <p:spPr>
             <a:xfrm>
-              <a:off x="1706289" y="952357"/>
-              <a:ext cx="2397500" cy="2935799"/>
+              <a:off x="1794699" y="952357"/>
+              <a:ext cx="2309090" cy="2890515"/>
             </a:xfrm>
             <a:prstGeom prst="rect">
               <a:avLst/>
@@ -2350,15 +2350,15 @@
           </p:nvSpPr>
           <p:spPr>
             <a:xfrm>
-              <a:off x="2929825" y="952357"/>
-              <a:ext cx="0" cy="2935799"/>
+              <a:off x="2973116" y="952357"/>
+              <a:ext cx="0" cy="2890515"/>
             </a:xfrm>
             <a:custGeom>
               <a:avLst/>
               <a:pathLst>
-                <a:path w="0" h="2935799">
+                <a:path w="0" h="2890515">
                   <a:moveTo>
-                    <a:pt x="0" y="2935799"/>
+                    <a:pt x="0" y="2890515"/>
                   </a:moveTo>
                   <a:lnTo>
                     <a:pt x="0" y="0"/>
@@ -2393,15 +2393,15 @@
           </p:nvSpPr>
           <p:spPr>
             <a:xfrm>
-              <a:off x="2782563" y="1048930"/>
-              <a:ext cx="0" cy="38628"/>
+              <a:off x="2831284" y="1047440"/>
+              <a:ext cx="0" cy="38033"/>
             </a:xfrm>
             <a:custGeom>
               <a:avLst/>
               <a:pathLst>
-                <a:path w="0" h="38628">
+                <a:path w="0" h="38033">
                   <a:moveTo>
-                    <a:pt x="0" y="38628"/>
+                    <a:pt x="0" y="38033"/>
                   </a:moveTo>
                   <a:lnTo>
                     <a:pt x="0" y="0"/>
@@ -2433,15 +2433,15 @@
           </p:nvSpPr>
           <p:spPr>
             <a:xfrm>
-              <a:off x="2588443" y="1068244"/>
-              <a:ext cx="194120" cy="0"/>
+              <a:off x="2644323" y="1066456"/>
+              <a:ext cx="186961" cy="0"/>
             </a:xfrm>
             <a:custGeom>
               <a:avLst/>
               <a:pathLst>
-                <a:path w="194120" h="0">
+                <a:path w="186961" h="0">
                   <a:moveTo>
-                    <a:pt x="194120" y="0"/>
+                    <a:pt x="186961" y="0"/>
                   </a:moveTo>
                   <a:lnTo>
                     <a:pt x="0" y="0"/>
@@ -2473,15 +2473,15 @@
           </p:nvSpPr>
           <p:spPr>
             <a:xfrm>
-              <a:off x="2588443" y="1048930"/>
-              <a:ext cx="0" cy="38628"/>
+              <a:off x="2644323" y="1047440"/>
+              <a:ext cx="0" cy="38033"/>
             </a:xfrm>
             <a:custGeom>
               <a:avLst/>
               <a:pathLst>
-                <a:path w="0" h="38628">
+                <a:path w="0" h="38033">
                   <a:moveTo>
-                    <a:pt x="0" y="38628"/>
+                    <a:pt x="0" y="38033"/>
                   </a:moveTo>
                   <a:lnTo>
                     <a:pt x="0" y="0"/>
@@ -2513,15 +2513,15 @@
           </p:nvSpPr>
           <p:spPr>
             <a:xfrm>
-              <a:off x="3900120" y="1242074"/>
-              <a:ext cx="0" cy="38628"/>
+              <a:off x="3907631" y="1237605"/>
+              <a:ext cx="0" cy="38033"/>
             </a:xfrm>
             <a:custGeom>
               <a:avLst/>
               <a:pathLst>
-                <a:path w="0" h="38628">
+                <a:path w="0" h="38033">
                   <a:moveTo>
-                    <a:pt x="0" y="38628"/>
+                    <a:pt x="0" y="38033"/>
                   </a:moveTo>
                   <a:lnTo>
                     <a:pt x="0" y="0"/>
@@ -2553,15 +2553,15 @@
           </p:nvSpPr>
           <p:spPr>
             <a:xfrm>
-              <a:off x="3050251" y="1261389"/>
-              <a:ext cx="849869" cy="0"/>
+              <a:off x="3089101" y="1256622"/>
+              <a:ext cx="818530" cy="0"/>
             </a:xfrm>
             <a:custGeom>
               <a:avLst/>
               <a:pathLst>
-                <a:path w="849869" h="0">
+                <a:path w="818530" h="0">
                   <a:moveTo>
-                    <a:pt x="849869" y="0"/>
+                    <a:pt x="818530" y="0"/>
                   </a:moveTo>
                   <a:lnTo>
                     <a:pt x="0" y="0"/>
@@ -2593,15 +2593,15 @@
           </p:nvSpPr>
           <p:spPr>
             <a:xfrm>
-              <a:off x="3050251" y="1242074"/>
-              <a:ext cx="0" cy="38628"/>
+              <a:off x="3089101" y="1237605"/>
+              <a:ext cx="0" cy="38033"/>
             </a:xfrm>
             <a:custGeom>
               <a:avLst/>
               <a:pathLst>
-                <a:path w="0" h="38628">
+                <a:path w="0" h="38033">
                   <a:moveTo>
-                    <a:pt x="0" y="38628"/>
+                    <a:pt x="0" y="38033"/>
                   </a:moveTo>
                   <a:lnTo>
                     <a:pt x="0" y="0"/>
@@ -2633,15 +2633,15 @@
           </p:nvSpPr>
           <p:spPr>
             <a:xfrm>
-              <a:off x="3966762" y="1435219"/>
-              <a:ext cx="0" cy="38628"/>
+              <a:off x="3971815" y="1427771"/>
+              <a:ext cx="0" cy="38033"/>
             </a:xfrm>
             <a:custGeom>
               <a:avLst/>
               <a:pathLst>
-                <a:path w="0" h="38628">
+                <a:path w="0" h="38033">
                   <a:moveTo>
-                    <a:pt x="0" y="38628"/>
+                    <a:pt x="0" y="38033"/>
                   </a:moveTo>
                   <a:lnTo>
                     <a:pt x="0" y="0"/>
@@ -2673,15 +2673,15 @@
           </p:nvSpPr>
           <p:spPr>
             <a:xfrm>
-              <a:off x="3141449" y="1454533"/>
-              <a:ext cx="825312" cy="0"/>
+              <a:off x="3176936" y="1446787"/>
+              <a:ext cx="794878" cy="0"/>
             </a:xfrm>
             <a:custGeom>
               <a:avLst/>
               <a:pathLst>
-                <a:path w="825312" h="0">
+                <a:path w="794878" h="0">
                   <a:moveTo>
-                    <a:pt x="825312" y="0"/>
+                    <a:pt x="794878" y="0"/>
                   </a:moveTo>
                   <a:lnTo>
                     <a:pt x="0" y="0"/>
@@ -2713,15 +2713,15 @@
           </p:nvSpPr>
           <p:spPr>
             <a:xfrm>
-              <a:off x="3141449" y="1435219"/>
-              <a:ext cx="0" cy="38628"/>
+              <a:off x="3176936" y="1427771"/>
+              <a:ext cx="0" cy="38033"/>
             </a:xfrm>
             <a:custGeom>
               <a:avLst/>
               <a:pathLst>
-                <a:path w="0" h="38628">
+                <a:path w="0" h="38033">
                   <a:moveTo>
-                    <a:pt x="0" y="38628"/>
+                    <a:pt x="0" y="38033"/>
                   </a:moveTo>
                   <a:lnTo>
                     <a:pt x="0" y="0"/>
@@ -2753,15 +2753,15 @@
           </p:nvSpPr>
           <p:spPr>
             <a:xfrm>
-              <a:off x="2908732" y="1628364"/>
-              <a:ext cx="0" cy="38628"/>
+              <a:off x="2952800" y="1617936"/>
+              <a:ext cx="0" cy="38033"/>
             </a:xfrm>
             <a:custGeom>
               <a:avLst/>
               <a:pathLst>
-                <a:path w="0" h="38628">
+                <a:path w="0" h="38033">
                   <a:moveTo>
-                    <a:pt x="0" y="38628"/>
+                    <a:pt x="0" y="38033"/>
                   </a:moveTo>
                   <a:lnTo>
                     <a:pt x="0" y="0"/>
@@ -2793,15 +2793,15 @@
           </p:nvSpPr>
           <p:spPr>
             <a:xfrm>
-              <a:off x="2462654" y="1647678"/>
-              <a:ext cx="446077" cy="0"/>
+              <a:off x="2523172" y="1636953"/>
+              <a:ext cx="429628" cy="0"/>
             </a:xfrm>
             <a:custGeom>
               <a:avLst/>
               <a:pathLst>
-                <a:path w="446077" h="0">
+                <a:path w="429628" h="0">
                   <a:moveTo>
-                    <a:pt x="446077" y="0"/>
+                    <a:pt x="429628" y="0"/>
                   </a:moveTo>
                   <a:lnTo>
                     <a:pt x="0" y="0"/>
@@ -2833,15 +2833,15 @@
           </p:nvSpPr>
           <p:spPr>
             <a:xfrm>
-              <a:off x="2462654" y="1628364"/>
-              <a:ext cx="0" cy="38628"/>
+              <a:off x="2523172" y="1617936"/>
+              <a:ext cx="0" cy="38033"/>
             </a:xfrm>
             <a:custGeom>
               <a:avLst/>
               <a:pathLst>
-                <a:path w="0" h="38628">
+                <a:path w="0" h="38033">
                   <a:moveTo>
-                    <a:pt x="0" y="38628"/>
+                    <a:pt x="0" y="38033"/>
                   </a:moveTo>
                   <a:lnTo>
                     <a:pt x="0" y="0"/>
@@ -2873,15 +2873,15 @@
           </p:nvSpPr>
           <p:spPr>
             <a:xfrm>
-              <a:off x="2612043" y="1821508"/>
-              <a:ext cx="0" cy="38628"/>
+              <a:off x="2667052" y="1808102"/>
+              <a:ext cx="0" cy="38033"/>
             </a:xfrm>
             <a:custGeom>
               <a:avLst/>
               <a:pathLst>
-                <a:path w="0" h="38628">
+                <a:path w="0" h="38033">
                   <a:moveTo>
-                    <a:pt x="0" y="38628"/>
+                    <a:pt x="0" y="38033"/>
                   </a:moveTo>
                   <a:lnTo>
                     <a:pt x="0" y="0"/>
@@ -2913,15 +2913,15 @@
           </p:nvSpPr>
           <p:spPr>
             <a:xfrm>
-              <a:off x="1815266" y="1840823"/>
-              <a:ext cx="796776" cy="0"/>
+              <a:off x="1899657" y="1827119"/>
+              <a:ext cx="767394" cy="0"/>
             </a:xfrm>
             <a:custGeom>
               <a:avLst/>
               <a:pathLst>
-                <a:path w="796776" h="0">
+                <a:path w="767394" h="0">
                   <a:moveTo>
-                    <a:pt x="796776" y="0"/>
+                    <a:pt x="767394" y="0"/>
                   </a:moveTo>
                   <a:lnTo>
                     <a:pt x="0" y="0"/>
@@ -2953,15 +2953,15 @@
           </p:nvSpPr>
           <p:spPr>
             <a:xfrm>
-              <a:off x="1815266" y="1821508"/>
-              <a:ext cx="0" cy="38628"/>
+              <a:off x="1899657" y="1808102"/>
+              <a:ext cx="0" cy="38033"/>
             </a:xfrm>
             <a:custGeom>
               <a:avLst/>
               <a:pathLst>
-                <a:path w="0" h="38628">
+                <a:path w="0" h="38033">
                   <a:moveTo>
-                    <a:pt x="0" y="38628"/>
+                    <a:pt x="0" y="38033"/>
                   </a:moveTo>
                   <a:lnTo>
                     <a:pt x="0" y="0"/>
@@ -2993,15 +2993,15 @@
           </p:nvSpPr>
           <p:spPr>
             <a:xfrm>
-              <a:off x="3639890" y="2014653"/>
-              <a:ext cx="0" cy="38628"/>
+              <a:off x="3656996" y="1998267"/>
+              <a:ext cx="0" cy="38033"/>
             </a:xfrm>
             <a:custGeom>
               <a:avLst/>
               <a:pathLst>
-                <a:path w="0" h="38628">
+                <a:path w="0" h="38033">
                   <a:moveTo>
-                    <a:pt x="0" y="38628"/>
+                    <a:pt x="0" y="38033"/>
                   </a:moveTo>
                   <a:lnTo>
                     <a:pt x="0" y="0"/>
@@ -3033,15 +3033,15 @@
           </p:nvSpPr>
           <p:spPr>
             <a:xfrm>
-              <a:off x="2662935" y="2033968"/>
-              <a:ext cx="976954" cy="0"/>
+              <a:off x="2716067" y="2017284"/>
+              <a:ext cx="940928" cy="0"/>
             </a:xfrm>
             <a:custGeom>
               <a:avLst/>
               <a:pathLst>
-                <a:path w="976954" h="0">
+                <a:path w="940928" h="0">
                   <a:moveTo>
-                    <a:pt x="976954" y="0"/>
+                    <a:pt x="940928" y="0"/>
                   </a:moveTo>
                   <a:lnTo>
                     <a:pt x="0" y="0"/>
@@ -3073,15 +3073,15 @@
           </p:nvSpPr>
           <p:spPr>
             <a:xfrm>
-              <a:off x="2662935" y="2014653"/>
-              <a:ext cx="0" cy="38628"/>
+              <a:off x="2716067" y="1998267"/>
+              <a:ext cx="0" cy="38033"/>
             </a:xfrm>
             <a:custGeom>
               <a:avLst/>
               <a:pathLst>
-                <a:path w="0" h="38628">
+                <a:path w="0" h="38033">
                   <a:moveTo>
-                    <a:pt x="0" y="38628"/>
+                    <a:pt x="0" y="38033"/>
                   </a:moveTo>
                   <a:lnTo>
                     <a:pt x="0" y="0"/>
@@ -3113,15 +3113,15 @@
           </p:nvSpPr>
           <p:spPr>
             <a:xfrm>
-              <a:off x="3152690" y="2207798"/>
-              <a:ext cx="0" cy="38628"/>
+              <a:off x="3187762" y="2188433"/>
+              <a:ext cx="0" cy="38033"/>
             </a:xfrm>
             <a:custGeom>
               <a:avLst/>
               <a:pathLst>
-                <a:path w="0" h="38628">
+                <a:path w="0" h="38033">
                   <a:moveTo>
-                    <a:pt x="0" y="38628"/>
+                    <a:pt x="0" y="38033"/>
                   </a:moveTo>
                   <a:lnTo>
                     <a:pt x="0" y="0"/>
@@ -3153,15 +3153,15 @@
           </p:nvSpPr>
           <p:spPr>
             <a:xfrm>
-              <a:off x="2872317" y="2227112"/>
-              <a:ext cx="280372" cy="0"/>
+              <a:off x="2917728" y="2207450"/>
+              <a:ext cx="270033" cy="0"/>
             </a:xfrm>
             <a:custGeom>
               <a:avLst/>
               <a:pathLst>
-                <a:path w="280372" h="0">
+                <a:path w="270033" h="0">
                   <a:moveTo>
-                    <a:pt x="280372" y="0"/>
+                    <a:pt x="270033" y="0"/>
                   </a:moveTo>
                   <a:lnTo>
                     <a:pt x="0" y="0"/>
@@ -3193,15 +3193,15 @@
           </p:nvSpPr>
           <p:spPr>
             <a:xfrm>
-              <a:off x="2872317" y="2207798"/>
-              <a:ext cx="0" cy="38628"/>
+              <a:off x="2917728" y="2188433"/>
+              <a:ext cx="0" cy="38033"/>
             </a:xfrm>
             <a:custGeom>
               <a:avLst/>
               <a:pathLst>
-                <a:path w="0" h="38628">
+                <a:path w="0" h="38033">
                   <a:moveTo>
-                    <a:pt x="0" y="38628"/>
+                    <a:pt x="0" y="38033"/>
                   </a:moveTo>
                   <a:lnTo>
                     <a:pt x="0" y="0"/>
@@ -3233,15 +3233,15 @@
           </p:nvSpPr>
           <p:spPr>
             <a:xfrm>
-              <a:off x="3994812" y="2400942"/>
-              <a:ext cx="0" cy="38628"/>
+              <a:off x="3998831" y="2378598"/>
+              <a:ext cx="0" cy="38033"/>
             </a:xfrm>
             <a:custGeom>
               <a:avLst/>
               <a:pathLst>
-                <a:path w="0" h="38628">
+                <a:path w="0" h="38033">
                   <a:moveTo>
-                    <a:pt x="0" y="38628"/>
+                    <a:pt x="0" y="38033"/>
                   </a:moveTo>
                   <a:lnTo>
                     <a:pt x="0" y="0"/>
@@ -3273,15 +3273,15 @@
           </p:nvSpPr>
           <p:spPr>
             <a:xfrm>
-              <a:off x="3274406" y="2420257"/>
-              <a:ext cx="720406" cy="0"/>
+              <a:off x="3304990" y="2397615"/>
+              <a:ext cx="693840" cy="0"/>
             </a:xfrm>
             <a:custGeom>
               <a:avLst/>
               <a:pathLst>
-                <a:path w="720406" h="0">
+                <a:path w="693840" h="0">
                   <a:moveTo>
-                    <a:pt x="720406" y="0"/>
+                    <a:pt x="693840" y="0"/>
                   </a:moveTo>
                   <a:lnTo>
                     <a:pt x="0" y="0"/>
@@ -3313,15 +3313,15 @@
           </p:nvSpPr>
           <p:spPr>
             <a:xfrm>
-              <a:off x="3274406" y="2400942"/>
-              <a:ext cx="0" cy="38628"/>
+              <a:off x="3304990" y="2378598"/>
+              <a:ext cx="0" cy="38033"/>
             </a:xfrm>
             <a:custGeom>
               <a:avLst/>
               <a:pathLst>
-                <a:path w="0" h="38628">
+                <a:path w="0" h="38033">
                   <a:moveTo>
-                    <a:pt x="0" y="38628"/>
+                    <a:pt x="0" y="38033"/>
                   </a:moveTo>
                   <a:lnTo>
                     <a:pt x="0" y="0"/>
@@ -3353,15 +3353,15 @@
           </p:nvSpPr>
           <p:spPr>
             <a:xfrm>
-              <a:off x="3029494" y="2594087"/>
-              <a:ext cx="0" cy="38628"/>
+              <a:off x="3069110" y="2568764"/>
+              <a:ext cx="0" cy="38033"/>
             </a:xfrm>
             <a:custGeom>
               <a:avLst/>
               <a:pathLst>
-                <a:path w="0" h="38628">
+                <a:path w="0" h="38033">
                   <a:moveTo>
-                    <a:pt x="0" y="38628"/>
+                    <a:pt x="0" y="38033"/>
                   </a:moveTo>
                   <a:lnTo>
                     <a:pt x="0" y="0"/>
@@ -3393,15 +3393,15 @@
           </p:nvSpPr>
           <p:spPr>
             <a:xfrm>
-              <a:off x="2580511" y="2613402"/>
-              <a:ext cx="448983" cy="0"/>
+              <a:off x="2636683" y="2587781"/>
+              <a:ext cx="432426" cy="0"/>
             </a:xfrm>
             <a:custGeom>
               <a:avLst/>
               <a:pathLst>
-                <a:path w="448983" h="0">
+                <a:path w="432426" h="0">
                   <a:moveTo>
-                    <a:pt x="448983" y="0"/>
+                    <a:pt x="432426" y="0"/>
                   </a:moveTo>
                   <a:lnTo>
                     <a:pt x="0" y="0"/>
@@ -3433,15 +3433,15 @@
           </p:nvSpPr>
           <p:spPr>
             <a:xfrm>
-              <a:off x="2580511" y="2594087"/>
-              <a:ext cx="0" cy="38628"/>
+              <a:off x="2636683" y="2568764"/>
+              <a:ext cx="0" cy="38033"/>
             </a:xfrm>
             <a:custGeom>
               <a:avLst/>
               <a:pathLst>
-                <a:path w="0" h="38628">
+                <a:path w="0" h="38033">
                   <a:moveTo>
-                    <a:pt x="0" y="38628"/>
+                    <a:pt x="0" y="38033"/>
                   </a:moveTo>
                   <a:lnTo>
                     <a:pt x="0" y="0"/>
@@ -3473,15 +3473,15 @@
           </p:nvSpPr>
           <p:spPr>
             <a:xfrm>
-              <a:off x="2871293" y="2787232"/>
-              <a:ext cx="0" cy="38628"/>
+              <a:off x="2916743" y="2758930"/>
+              <a:ext cx="0" cy="38033"/>
             </a:xfrm>
             <a:custGeom>
               <a:avLst/>
               <a:pathLst>
-                <a:path w="0" h="38628">
+                <a:path w="0" h="38033">
                   <a:moveTo>
-                    <a:pt x="0" y="38628"/>
+                    <a:pt x="0" y="38033"/>
                   </a:moveTo>
                   <a:lnTo>
                     <a:pt x="0" y="0"/>
@@ -3513,15 +3513,15 @@
           </p:nvSpPr>
           <p:spPr>
             <a:xfrm>
-              <a:off x="2401840" y="2806546"/>
-              <a:ext cx="469453" cy="0"/>
+              <a:off x="2464600" y="2777946"/>
+              <a:ext cx="452142" cy="0"/>
             </a:xfrm>
             <a:custGeom>
               <a:avLst/>
               <a:pathLst>
-                <a:path w="469453" h="0">
+                <a:path w="452142" h="0">
                   <a:moveTo>
-                    <a:pt x="469453" y="0"/>
+                    <a:pt x="452142" y="0"/>
                   </a:moveTo>
                   <a:lnTo>
                     <a:pt x="0" y="0"/>
@@ -3553,15 +3553,15 @@
           </p:nvSpPr>
           <p:spPr>
             <a:xfrm>
-              <a:off x="2401840" y="2787232"/>
-              <a:ext cx="0" cy="38628"/>
+              <a:off x="2464600" y="2758930"/>
+              <a:ext cx="0" cy="38033"/>
             </a:xfrm>
             <a:custGeom>
               <a:avLst/>
               <a:pathLst>
-                <a:path w="0" h="38628">
+                <a:path w="0" h="38033">
                   <a:moveTo>
-                    <a:pt x="0" y="38628"/>
+                    <a:pt x="0" y="38033"/>
                   </a:moveTo>
                   <a:lnTo>
                     <a:pt x="0" y="0"/>
@@ -3593,15 +3593,15 @@
           </p:nvSpPr>
           <p:spPr>
             <a:xfrm>
-              <a:off x="3590937" y="2980377"/>
-              <a:ext cx="0" cy="38628"/>
+              <a:off x="3609849" y="2949095"/>
+              <a:ext cx="0" cy="38033"/>
             </a:xfrm>
             <a:custGeom>
               <a:avLst/>
               <a:pathLst>
-                <a:path w="0" h="38628">
+                <a:path w="0" h="38033">
                   <a:moveTo>
-                    <a:pt x="0" y="38628"/>
+                    <a:pt x="0" y="38033"/>
                   </a:moveTo>
                   <a:lnTo>
                     <a:pt x="0" y="0"/>
@@ -3633,15 +3633,15 @@
           </p:nvSpPr>
           <p:spPr>
             <a:xfrm>
-              <a:off x="3147638" y="2999691"/>
-              <a:ext cx="443298" cy="0"/>
+              <a:off x="3182897" y="2968112"/>
+              <a:ext cx="426952" cy="0"/>
             </a:xfrm>
             <a:custGeom>
               <a:avLst/>
               <a:pathLst>
-                <a:path w="443298" h="0">
+                <a:path w="426952" h="0">
                   <a:moveTo>
-                    <a:pt x="443298" y="0"/>
+                    <a:pt x="426952" y="0"/>
                   </a:moveTo>
                   <a:lnTo>
                     <a:pt x="0" y="0"/>
@@ -3673,15 +3673,15 @@
           </p:nvSpPr>
           <p:spPr>
             <a:xfrm>
-              <a:off x="3147638" y="2980377"/>
-              <a:ext cx="0" cy="38628"/>
+              <a:off x="3182897" y="2949095"/>
+              <a:ext cx="0" cy="38033"/>
             </a:xfrm>
             <a:custGeom>
               <a:avLst/>
               <a:pathLst>
-                <a:path w="0" h="38628">
+                <a:path w="0" h="38033">
                   <a:moveTo>
-                    <a:pt x="0" y="38628"/>
+                    <a:pt x="0" y="38033"/>
                   </a:moveTo>
                   <a:lnTo>
                     <a:pt x="0" y="0"/>
@@ -3713,15 +3713,15 @@
           </p:nvSpPr>
           <p:spPr>
             <a:xfrm>
-              <a:off x="3481488" y="3173521"/>
-              <a:ext cx="0" cy="38628"/>
+              <a:off x="3504436" y="3139261"/>
+              <a:ext cx="0" cy="38033"/>
             </a:xfrm>
             <a:custGeom>
               <a:avLst/>
               <a:pathLst>
-                <a:path w="0" h="38628">
+                <a:path w="0" h="38033">
                   <a:moveTo>
-                    <a:pt x="0" y="38628"/>
+                    <a:pt x="0" y="38033"/>
                   </a:moveTo>
                   <a:lnTo>
                     <a:pt x="0" y="0"/>
@@ -3753,15 +3753,15 @@
           </p:nvSpPr>
           <p:spPr>
             <a:xfrm>
-              <a:off x="2320128" y="3192836"/>
-              <a:ext cx="1161360" cy="0"/>
+              <a:off x="2385901" y="3158277"/>
+              <a:ext cx="1118534" cy="0"/>
             </a:xfrm>
             <a:custGeom>
               <a:avLst/>
               <a:pathLst>
-                <a:path w="1161360" h="0">
+                <a:path w="1118534" h="0">
                   <a:moveTo>
-                    <a:pt x="1161360" y="0"/>
+                    <a:pt x="1118534" y="0"/>
                   </a:moveTo>
                   <a:lnTo>
                     <a:pt x="0" y="0"/>
@@ -3793,15 +3793,15 @@
           </p:nvSpPr>
           <p:spPr>
             <a:xfrm>
-              <a:off x="2320128" y="3173521"/>
-              <a:ext cx="0" cy="38628"/>
+              <a:off x="2385901" y="3139261"/>
+              <a:ext cx="0" cy="38033"/>
             </a:xfrm>
             <a:custGeom>
               <a:avLst/>
               <a:pathLst>
-                <a:path w="0" h="38628">
+                <a:path w="0" h="38033">
                   <a:moveTo>
-                    <a:pt x="0" y="38628"/>
+                    <a:pt x="0" y="38033"/>
                   </a:moveTo>
                   <a:lnTo>
                     <a:pt x="0" y="0"/>
@@ -3833,15 +3833,15 @@
           </p:nvSpPr>
           <p:spPr>
             <a:xfrm>
-              <a:off x="3229900" y="3366666"/>
-              <a:ext cx="0" cy="38628"/>
+              <a:off x="3262126" y="3329426"/>
+              <a:ext cx="0" cy="38033"/>
             </a:xfrm>
             <a:custGeom>
               <a:avLst/>
               <a:pathLst>
-                <a:path w="0" h="38628">
+                <a:path w="0" h="38033">
                   <a:moveTo>
-                    <a:pt x="0" y="38628"/>
+                    <a:pt x="0" y="38033"/>
                   </a:moveTo>
                   <a:lnTo>
                     <a:pt x="0" y="0"/>
@@ -3873,15 +3873,15 @@
           </p:nvSpPr>
           <p:spPr>
             <a:xfrm>
-              <a:off x="2120072" y="3385980"/>
-              <a:ext cx="1109828" cy="0"/>
+              <a:off x="2193223" y="3348443"/>
+              <a:ext cx="1068902" cy="0"/>
             </a:xfrm>
             <a:custGeom>
               <a:avLst/>
               <a:pathLst>
-                <a:path w="1109828" h="0">
+                <a:path w="1068902" h="0">
                   <a:moveTo>
-                    <a:pt x="1109828" y="0"/>
+                    <a:pt x="1068902" y="0"/>
                   </a:moveTo>
                   <a:lnTo>
                     <a:pt x="0" y="0"/>
@@ -3913,15 +3913,15 @@
           </p:nvSpPr>
           <p:spPr>
             <a:xfrm>
-              <a:off x="2120072" y="3366666"/>
-              <a:ext cx="0" cy="38628"/>
+              <a:off x="2193223" y="3329426"/>
+              <a:ext cx="0" cy="38033"/>
             </a:xfrm>
             <a:custGeom>
               <a:avLst/>
               <a:pathLst>
-                <a:path w="0" h="38628">
+                <a:path w="0" h="38033">
                   <a:moveTo>
-                    <a:pt x="0" y="38628"/>
+                    <a:pt x="0" y="38033"/>
                   </a:moveTo>
                   <a:lnTo>
                     <a:pt x="0" y="0"/>
@@ -3953,15 +3953,15 @@
           </p:nvSpPr>
           <p:spPr>
             <a:xfrm>
-              <a:off x="3409038" y="3559811"/>
-              <a:ext cx="0" cy="38628"/>
+              <a:off x="3434657" y="3519592"/>
+              <a:ext cx="0" cy="38033"/>
             </a:xfrm>
             <a:custGeom>
               <a:avLst/>
               <a:pathLst>
-                <a:path w="0" h="38628">
+                <a:path w="0" h="38033">
                   <a:moveTo>
-                    <a:pt x="0" y="38628"/>
+                    <a:pt x="0" y="38033"/>
                   </a:moveTo>
                   <a:lnTo>
                     <a:pt x="0" y="0"/>
@@ -3993,15 +3993,15 @@
           </p:nvSpPr>
           <p:spPr>
             <a:xfrm>
-              <a:off x="2209342" y="3579125"/>
-              <a:ext cx="1199695" cy="0"/>
+              <a:off x="2279201" y="3538608"/>
+              <a:ext cx="1155455" cy="0"/>
             </a:xfrm>
             <a:custGeom>
               <a:avLst/>
               <a:pathLst>
-                <a:path w="1199695" h="0">
+                <a:path w="1155455" h="0">
                   <a:moveTo>
-                    <a:pt x="1199695" y="0"/>
+                    <a:pt x="1155455" y="0"/>
                   </a:moveTo>
                   <a:lnTo>
                     <a:pt x="0" y="0"/>
@@ -4033,15 +4033,15 @@
           </p:nvSpPr>
           <p:spPr>
             <a:xfrm>
-              <a:off x="2209342" y="3559811"/>
-              <a:ext cx="0" cy="38628"/>
+              <a:off x="2279201" y="3519592"/>
+              <a:ext cx="0" cy="38033"/>
             </a:xfrm>
             <a:custGeom>
               <a:avLst/>
               <a:pathLst>
-                <a:path w="0" h="38628">
+                <a:path w="0" h="38033">
                   <a:moveTo>
-                    <a:pt x="0" y="38628"/>
+                    <a:pt x="0" y="38033"/>
                   </a:moveTo>
                   <a:lnTo>
                     <a:pt x="0" y="0"/>
@@ -4073,15 +4073,15 @@
           </p:nvSpPr>
           <p:spPr>
             <a:xfrm>
-              <a:off x="2724739" y="3752955"/>
-              <a:ext cx="0" cy="38628"/>
+              <a:off x="2775593" y="3709757"/>
+              <a:ext cx="0" cy="38033"/>
             </a:xfrm>
             <a:custGeom>
               <a:avLst/>
               <a:pathLst>
-                <a:path w="0" h="38628">
+                <a:path w="0" h="38033">
                   <a:moveTo>
-                    <a:pt x="0" y="38628"/>
+                    <a:pt x="0" y="38033"/>
                   </a:moveTo>
                   <a:lnTo>
                     <a:pt x="0" y="0"/>
@@ -4113,15 +4113,15 @@
           </p:nvSpPr>
           <p:spPr>
             <a:xfrm>
-              <a:off x="2274188" y="3772270"/>
-              <a:ext cx="450551" cy="0"/>
+              <a:off x="2341655" y="3728774"/>
+              <a:ext cx="433937" cy="0"/>
             </a:xfrm>
             <a:custGeom>
               <a:avLst/>
               <a:pathLst>
-                <a:path w="450551" h="0">
+                <a:path w="433937" h="0">
                   <a:moveTo>
-                    <a:pt x="450551" y="0"/>
+                    <a:pt x="433937" y="0"/>
                   </a:moveTo>
                   <a:lnTo>
                     <a:pt x="0" y="0"/>
@@ -4153,15 +4153,15 @@
           </p:nvSpPr>
           <p:spPr>
             <a:xfrm>
-              <a:off x="2274188" y="3752955"/>
-              <a:ext cx="0" cy="38628"/>
+              <a:off x="2341655" y="3709757"/>
+              <a:ext cx="0" cy="38033"/>
             </a:xfrm>
             <a:custGeom>
               <a:avLst/>
               <a:pathLst>
-                <a:path w="0" h="38628">
+                <a:path w="0" h="38033">
                   <a:moveTo>
-                    <a:pt x="0" y="38628"/>
+                    <a:pt x="0" y="38033"/>
                   </a:moveTo>
                   <a:lnTo>
                     <a:pt x="0" y="0"/>
@@ -4193,7 +4193,7 @@
           </p:nvSpPr>
           <p:spPr>
             <a:xfrm>
-              <a:off x="2634051" y="1016792"/>
+              <a:off x="2686352" y="1015005"/>
               <a:ext cx="102903" cy="102903"/>
             </a:xfrm>
             <a:prstGeom prst="ellipse">
@@ -4228,7 +4228,7 @@
           </p:nvSpPr>
           <p:spPr>
             <a:xfrm>
-              <a:off x="3423734" y="1209937"/>
+              <a:off x="3446914" y="1205170"/>
               <a:ext cx="102903" cy="102903"/>
             </a:xfrm>
             <a:prstGeom prst="ellipse">
@@ -4263,7 +4263,7 @@
           </p:nvSpPr>
           <p:spPr>
             <a:xfrm>
-              <a:off x="3502654" y="1403082"/>
+              <a:off x="3522924" y="1395336"/>
               <a:ext cx="102903" cy="102903"/>
             </a:xfrm>
             <a:prstGeom prst="ellipse">
@@ -4298,7 +4298,7 @@
           </p:nvSpPr>
           <p:spPr>
             <a:xfrm>
-              <a:off x="2634241" y="1596226"/>
+              <a:off x="2686535" y="1585501"/>
               <a:ext cx="102903" cy="102903"/>
             </a:xfrm>
             <a:prstGeom prst="ellipse">
@@ -4333,7 +4333,7 @@
           </p:nvSpPr>
           <p:spPr>
             <a:xfrm>
-              <a:off x="2162203" y="1789371"/>
+              <a:off x="2231903" y="1775667"/>
               <a:ext cx="102903" cy="102903"/>
             </a:xfrm>
             <a:prstGeom prst="ellipse">
@@ -4368,7 +4368,7 @@
           </p:nvSpPr>
           <p:spPr>
             <a:xfrm>
-              <a:off x="3099960" y="1982516"/>
+              <a:off x="3135080" y="1965832"/>
               <a:ext cx="102903" cy="102903"/>
             </a:xfrm>
             <a:prstGeom prst="ellipse">
@@ -4403,7 +4403,7 @@
           </p:nvSpPr>
           <p:spPr>
             <a:xfrm>
-              <a:off x="2961051" y="2175660"/>
+              <a:off x="3001293" y="2155998"/>
               <a:ext cx="102903" cy="102903"/>
             </a:xfrm>
             <a:prstGeom prst="ellipse">
@@ -4438,7 +4438,7 @@
           </p:nvSpPr>
           <p:spPr>
             <a:xfrm>
-              <a:off x="3583157" y="2368805"/>
+              <a:off x="3600458" y="2346163"/>
               <a:ext cx="102903" cy="102903"/>
             </a:xfrm>
             <a:prstGeom prst="ellipse">
@@ -4473,7 +4473,7 @@
           </p:nvSpPr>
           <p:spPr>
             <a:xfrm>
-              <a:off x="2753551" y="2561950"/>
+              <a:off x="2801444" y="2536329"/>
               <a:ext cx="102903" cy="102903"/>
             </a:xfrm>
             <a:prstGeom prst="ellipse">
@@ -4508,7 +4508,7 @@
           </p:nvSpPr>
           <p:spPr>
             <a:xfrm>
-              <a:off x="2585115" y="2755094"/>
+              <a:off x="2639220" y="2726494"/>
               <a:ext cx="102903" cy="102903"/>
             </a:xfrm>
             <a:prstGeom prst="ellipse">
@@ -4543,7 +4543,7 @@
           </p:nvSpPr>
           <p:spPr>
             <a:xfrm>
-              <a:off x="3317836" y="2948239"/>
+              <a:off x="3344921" y="2916660"/>
               <a:ext cx="102903" cy="102903"/>
             </a:xfrm>
             <a:prstGeom prst="ellipse">
@@ -4578,7 +4578,7 @@
           </p:nvSpPr>
           <p:spPr>
             <a:xfrm>
-              <a:off x="2849356" y="3141384"/>
+              <a:off x="2893717" y="3106825"/>
               <a:ext cx="102903" cy="102903"/>
             </a:xfrm>
             <a:prstGeom prst="ellipse">
@@ -4613,7 +4613,7 @@
           </p:nvSpPr>
           <p:spPr>
             <a:xfrm>
-              <a:off x="2623534" y="3334529"/>
+              <a:off x="2676223" y="3296991"/>
               <a:ext cx="102903" cy="102903"/>
             </a:xfrm>
             <a:prstGeom prst="ellipse">
@@ -4648,7 +4648,7 @@
           </p:nvSpPr>
           <p:spPr>
             <a:xfrm>
-              <a:off x="2757738" y="3527673"/>
+              <a:off x="2805477" y="3487156"/>
               <a:ext cx="102903" cy="102903"/>
             </a:xfrm>
             <a:prstGeom prst="ellipse">
@@ -4683,7 +4683,7 @@
           </p:nvSpPr>
           <p:spPr>
             <a:xfrm>
-              <a:off x="2448011" y="3720818"/>
+              <a:off x="2507172" y="3677322"/>
               <a:ext cx="102903" cy="102903"/>
             </a:xfrm>
             <a:prstGeom prst="ellipse">
@@ -4718,8 +4718,8 @@
           </p:nvSpPr>
           <p:spPr>
             <a:xfrm>
-              <a:off x="1706289" y="952357"/>
-              <a:ext cx="2397500" cy="2935799"/>
+              <a:off x="1794699" y="952357"/>
+              <a:ext cx="2309090" cy="2890515"/>
             </a:xfrm>
             <a:prstGeom prst="rect">
               <a:avLst/>
@@ -4739,15 +4739,15 @@
           </p:nvSpPr>
           <p:spPr>
             <a:xfrm>
-              <a:off x="1706289" y="952357"/>
-              <a:ext cx="0" cy="2935799"/>
+              <a:off x="1794699" y="952357"/>
+              <a:ext cx="0" cy="2890515"/>
             </a:xfrm>
             <a:custGeom>
               <a:avLst/>
               <a:pathLst>
-                <a:path w="0" h="2935799">
+                <a:path w="0" h="2890515">
                   <a:moveTo>
-                    <a:pt x="0" y="2935799"/>
+                    <a:pt x="0" y="2890515"/>
                   </a:moveTo>
                   <a:lnTo>
                     <a:pt x="0" y="0"/>
@@ -4755,7 +4755,7 @@
                 </a:path>
               </a:pathLst>
             </a:custGeom>
-            <a:ln w="11086" cap="flat">
+            <a:ln w="12318" cap="flat">
               <a:solidFill>
                 <a:srgbClr val="000000">
                   <a:alpha val="100000"/>
@@ -4779,8 +4779,8 @@
           </p:nvSpPr>
           <p:spPr>
             <a:xfrm>
-              <a:off x="1124237" y="3735831"/>
-              <a:ext cx="530809" cy="72877"/>
+              <a:off x="1140476" y="3687763"/>
+              <a:ext cx="597286" cy="82021"/>
             </a:xfrm>
             <a:prstGeom prst="rect">
               <a:avLst/>
@@ -4793,7 +4793,7 @@
             <a:p>
               <a:pPr algn="l" marL="0" marR="0" indent="0">
                 <a:lnSpc>
-                  <a:spcPts val="800"/>
+                  <a:spcPts val="900"/>
                 </a:lnSpc>
                 <a:spcBef>
                   <a:spcPts val="0"/>
@@ -4803,7 +4803,7 @@
                 </a:spcAft>
               </a:pPr>
               <a:r>
-                <a:rPr sz="800">
+                <a:rPr sz="900">
                   <a:solidFill>
                     <a:srgbClr val="000000">
                       <a:alpha val="100000"/>
@@ -4825,8 +4825,8 @@
           </p:nvSpPr>
           <p:spPr>
             <a:xfrm>
-              <a:off x="1124237" y="3542686"/>
-              <a:ext cx="530809" cy="72877"/>
+              <a:off x="1140476" y="3497597"/>
+              <a:ext cx="597286" cy="82021"/>
             </a:xfrm>
             <a:prstGeom prst="rect">
               <a:avLst/>
@@ -4839,7 +4839,7 @@
             <a:p>
               <a:pPr algn="l" marL="0" marR="0" indent="0">
                 <a:lnSpc>
-                  <a:spcPts val="800"/>
+                  <a:spcPts val="900"/>
                 </a:lnSpc>
                 <a:spcBef>
                   <a:spcPts val="0"/>
@@ -4849,7 +4849,7 @@
                 </a:spcAft>
               </a:pPr>
               <a:r>
-                <a:rPr sz="800">
+                <a:rPr sz="900">
                   <a:solidFill>
                     <a:srgbClr val="000000">
                       <a:alpha val="100000"/>
@@ -4871,8 +4871,8 @@
           </p:nvSpPr>
           <p:spPr>
             <a:xfrm>
-              <a:off x="1446197" y="3349542"/>
-              <a:ext cx="208848" cy="72877"/>
+              <a:off x="1502670" y="3307432"/>
+              <a:ext cx="235092" cy="82021"/>
             </a:xfrm>
             <a:prstGeom prst="rect">
               <a:avLst/>
@@ -4885,7 +4885,7 @@
             <a:p>
               <a:pPr algn="l" marL="0" marR="0" indent="0">
                 <a:lnSpc>
-                  <a:spcPts val="800"/>
+                  <a:spcPts val="900"/>
                 </a:lnSpc>
                 <a:spcBef>
                   <a:spcPts val="0"/>
@@ -4895,7 +4895,7 @@
                 </a:spcAft>
               </a:pPr>
               <a:r>
-                <a:rPr sz="800">
+                <a:rPr sz="900">
                   <a:solidFill>
                     <a:srgbClr val="000000">
                       <a:alpha val="100000"/>
@@ -4917,8 +4917,8 @@
           </p:nvSpPr>
           <p:spPr>
             <a:xfrm>
-              <a:off x="1446289" y="3156397"/>
-              <a:ext cx="208757" cy="72877"/>
+              <a:off x="1502761" y="3117266"/>
+              <a:ext cx="235000" cy="82021"/>
             </a:xfrm>
             <a:prstGeom prst="rect">
               <a:avLst/>
@@ -4931,7 +4931,7 @@
             <a:p>
               <a:pPr algn="l" marL="0" marR="0" indent="0">
                 <a:lnSpc>
-                  <a:spcPts val="800"/>
+                  <a:spcPts val="900"/>
                 </a:lnSpc>
                 <a:spcBef>
                   <a:spcPts val="0"/>
@@ -4941,7 +4941,7 @@
                 </a:spcAft>
               </a:pPr>
               <a:r>
-                <a:rPr sz="800">
+                <a:rPr sz="900">
                   <a:solidFill>
                     <a:srgbClr val="000000">
                       <a:alpha val="100000"/>
@@ -4963,8 +4963,8 @@
           </p:nvSpPr>
           <p:spPr>
             <a:xfrm>
-              <a:off x="1508377" y="2963252"/>
-              <a:ext cx="146669" cy="72877"/>
+              <a:off x="1572622" y="2927101"/>
+              <a:ext cx="165140" cy="82021"/>
             </a:xfrm>
             <a:prstGeom prst="rect">
               <a:avLst/>
@@ -4977,7 +4977,7 @@
             <a:p>
               <a:pPr algn="l" marL="0" marR="0" indent="0">
                 <a:lnSpc>
-                  <a:spcPts val="800"/>
+                  <a:spcPts val="900"/>
                 </a:lnSpc>
                 <a:spcBef>
                   <a:spcPts val="0"/>
@@ -4987,7 +4987,7 @@
                 </a:spcAft>
               </a:pPr>
               <a:r>
-                <a:rPr sz="800">
+                <a:rPr sz="900">
                   <a:solidFill>
                     <a:srgbClr val="000000">
                       <a:alpha val="100000"/>
@@ -5009,8 +5009,8 @@
           </p:nvSpPr>
           <p:spPr>
             <a:xfrm>
-              <a:off x="1457445" y="2770107"/>
-              <a:ext cx="197601" cy="72877"/>
+              <a:off x="1515380" y="2736935"/>
+              <a:ext cx="222382" cy="82021"/>
             </a:xfrm>
             <a:prstGeom prst="rect">
               <a:avLst/>
@@ -5023,7 +5023,7 @@
             <a:p>
               <a:pPr algn="l" marL="0" marR="0" indent="0">
                 <a:lnSpc>
-                  <a:spcPts val="800"/>
+                  <a:spcPts val="900"/>
                 </a:lnSpc>
                 <a:spcBef>
                   <a:spcPts val="0"/>
@@ -5033,7 +5033,7 @@
                 </a:spcAft>
               </a:pPr>
               <a:r>
-                <a:rPr sz="800">
+                <a:rPr sz="900">
                   <a:solidFill>
                     <a:srgbClr val="000000">
                       <a:alpha val="100000"/>
@@ -5055,8 +5055,8 @@
           </p:nvSpPr>
           <p:spPr>
             <a:xfrm>
-              <a:off x="1112807" y="2576963"/>
-              <a:ext cx="542239" cy="72877"/>
+              <a:off x="1127766" y="2546770"/>
+              <a:ext cx="609996" cy="82021"/>
             </a:xfrm>
             <a:prstGeom prst="rect">
               <a:avLst/>
@@ -5069,7 +5069,7 @@
             <a:p>
               <a:pPr algn="l" marL="0" marR="0" indent="0">
                 <a:lnSpc>
-                  <a:spcPts val="800"/>
+                  <a:spcPts val="900"/>
                 </a:lnSpc>
                 <a:spcBef>
                   <a:spcPts val="0"/>
@@ -5079,7 +5079,7 @@
                 </a:spcAft>
               </a:pPr>
               <a:r>
-                <a:rPr sz="800">
+                <a:rPr sz="900">
                   <a:solidFill>
                     <a:srgbClr val="000000">
                       <a:alpha val="100000"/>
@@ -5101,8 +5101,8 @@
           </p:nvSpPr>
           <p:spPr>
             <a:xfrm>
-              <a:off x="1112807" y="2383818"/>
-              <a:ext cx="542239" cy="72877"/>
+              <a:off x="1127766" y="2356604"/>
+              <a:ext cx="609996" cy="82021"/>
             </a:xfrm>
             <a:prstGeom prst="rect">
               <a:avLst/>
@@ -5115,7 +5115,7 @@
             <a:p>
               <a:pPr algn="l" marL="0" marR="0" indent="0">
                 <a:lnSpc>
-                  <a:spcPts val="800"/>
+                  <a:spcPts val="900"/>
                 </a:lnSpc>
                 <a:spcBef>
                   <a:spcPts val="0"/>
@@ -5125,7 +5125,7 @@
                 </a:spcAft>
               </a:pPr>
               <a:r>
-                <a:rPr sz="800">
+                <a:rPr sz="900">
                   <a:solidFill>
                     <a:srgbClr val="000000">
                       <a:alpha val="100000"/>
@@ -5147,8 +5147,8 @@
           </p:nvSpPr>
           <p:spPr>
             <a:xfrm>
-              <a:off x="1361341" y="2190673"/>
-              <a:ext cx="293705" cy="72877"/>
+              <a:off x="1407390" y="2166439"/>
+              <a:ext cx="330372" cy="82021"/>
             </a:xfrm>
             <a:prstGeom prst="rect">
               <a:avLst/>
@@ -5161,7 +5161,7 @@
             <a:p>
               <a:pPr algn="l" marL="0" marR="0" indent="0">
                 <a:lnSpc>
-                  <a:spcPts val="800"/>
+                  <a:spcPts val="900"/>
                 </a:lnSpc>
                 <a:spcBef>
                   <a:spcPts val="0"/>
@@ -5171,7 +5171,7 @@
                 </a:spcAft>
               </a:pPr>
               <a:r>
-                <a:rPr sz="800">
+                <a:rPr sz="900">
                   <a:solidFill>
                     <a:srgbClr val="000000">
                       <a:alpha val="100000"/>
@@ -5193,8 +5193,8 @@
           </p:nvSpPr>
           <p:spPr>
             <a:xfrm>
-              <a:off x="1502616" y="1997529"/>
-              <a:ext cx="152430" cy="72877"/>
+              <a:off x="1566221" y="1976273"/>
+              <a:ext cx="171541" cy="82021"/>
             </a:xfrm>
             <a:prstGeom prst="rect">
               <a:avLst/>
@@ -5207,7 +5207,7 @@
             <a:p>
               <a:pPr algn="l" marL="0" marR="0" indent="0">
                 <a:lnSpc>
-                  <a:spcPts val="800"/>
+                  <a:spcPts val="900"/>
                 </a:lnSpc>
                 <a:spcBef>
                   <a:spcPts val="0"/>
@@ -5217,7 +5217,7 @@
                 </a:spcAft>
               </a:pPr>
               <a:r>
-                <a:rPr sz="800">
+                <a:rPr sz="900">
                   <a:solidFill>
                     <a:srgbClr val="000000">
                       <a:alpha val="100000"/>
@@ -5239,8 +5239,8 @@
           </p:nvSpPr>
           <p:spPr>
             <a:xfrm>
-              <a:off x="1446197" y="1804384"/>
-              <a:ext cx="208848" cy="72877"/>
+              <a:off x="1502670" y="1786108"/>
+              <a:ext cx="235092" cy="82021"/>
             </a:xfrm>
             <a:prstGeom prst="rect">
               <a:avLst/>
@@ -5253,7 +5253,7 @@
             <a:p>
               <a:pPr algn="l" marL="0" marR="0" indent="0">
                 <a:lnSpc>
-                  <a:spcPts val="800"/>
+                  <a:spcPts val="900"/>
                 </a:lnSpc>
                 <a:spcBef>
                   <a:spcPts val="0"/>
@@ -5263,7 +5263,7 @@
                 </a:spcAft>
               </a:pPr>
               <a:r>
-                <a:rPr sz="800">
+                <a:rPr sz="900">
                   <a:solidFill>
                     <a:srgbClr val="000000">
                       <a:alpha val="100000"/>
@@ -5285,8 +5285,8 @@
           </p:nvSpPr>
           <p:spPr>
             <a:xfrm>
-              <a:off x="1367193" y="1611239"/>
-              <a:ext cx="287853" cy="72877"/>
+              <a:off x="1413882" y="1595942"/>
+              <a:ext cx="323880" cy="82021"/>
             </a:xfrm>
             <a:prstGeom prst="rect">
               <a:avLst/>
@@ -5299,7 +5299,7 @@
             <a:p>
               <a:pPr algn="l" marL="0" marR="0" indent="0">
                 <a:lnSpc>
-                  <a:spcPts val="800"/>
+                  <a:spcPts val="900"/>
                 </a:lnSpc>
                 <a:spcBef>
                   <a:spcPts val="0"/>
@@ -5309,7 +5309,7 @@
                 </a:spcAft>
               </a:pPr>
               <a:r>
-                <a:rPr sz="800">
+                <a:rPr sz="900">
                   <a:solidFill>
                     <a:srgbClr val="000000">
                       <a:alpha val="100000"/>
@@ -5331,8 +5331,8 @@
           </p:nvSpPr>
           <p:spPr>
             <a:xfrm>
-              <a:off x="1463022" y="1418095"/>
-              <a:ext cx="192024" cy="72877"/>
+              <a:off x="1521690" y="1405777"/>
+              <a:ext cx="216072" cy="82021"/>
             </a:xfrm>
             <a:prstGeom prst="rect">
               <a:avLst/>
@@ -5345,7 +5345,7 @@
             <a:p>
               <a:pPr algn="l" marL="0" marR="0" indent="0">
                 <a:lnSpc>
-                  <a:spcPts val="800"/>
+                  <a:spcPts val="900"/>
                 </a:lnSpc>
                 <a:spcBef>
                   <a:spcPts val="0"/>
@@ -5355,7 +5355,7 @@
                 </a:spcAft>
               </a:pPr>
               <a:r>
-                <a:rPr sz="800">
+                <a:rPr sz="900">
                   <a:solidFill>
                     <a:srgbClr val="000000">
                       <a:alpha val="100000"/>
@@ -5377,8 +5377,8 @@
           </p:nvSpPr>
           <p:spPr>
             <a:xfrm>
-              <a:off x="1446106" y="1224950"/>
-              <a:ext cx="208940" cy="72877"/>
+              <a:off x="1502761" y="1215611"/>
+              <a:ext cx="235000" cy="82021"/>
             </a:xfrm>
             <a:prstGeom prst="rect">
               <a:avLst/>
@@ -5391,7 +5391,7 @@
             <a:p>
               <a:pPr algn="l" marL="0" marR="0" indent="0">
                 <a:lnSpc>
-                  <a:spcPts val="800"/>
+                  <a:spcPts val="900"/>
                 </a:lnSpc>
                 <a:spcBef>
                   <a:spcPts val="0"/>
@@ -5401,7 +5401,7 @@
                 </a:spcAft>
               </a:pPr>
               <a:r>
-                <a:rPr sz="800">
+                <a:rPr sz="900">
                   <a:solidFill>
                     <a:srgbClr val="000000">
                       <a:alpha val="100000"/>
@@ -5423,8 +5423,8 @@
           </p:nvSpPr>
           <p:spPr>
             <a:xfrm>
-              <a:off x="1457445" y="1031805"/>
-              <a:ext cx="197601" cy="72877"/>
+              <a:off x="1515472" y="1025446"/>
+              <a:ext cx="222290" cy="82021"/>
             </a:xfrm>
             <a:prstGeom prst="rect">
               <a:avLst/>
@@ -5437,7 +5437,7 @@
             <a:p>
               <a:pPr algn="l" marL="0" marR="0" indent="0">
                 <a:lnSpc>
-                  <a:spcPts val="800"/>
+                  <a:spcPts val="900"/>
                 </a:lnSpc>
                 <a:spcBef>
                   <a:spcPts val="0"/>
@@ -5447,7 +5447,7 @@
                 </a:spcAft>
               </a:pPr>
               <a:r>
-                <a:rPr sz="800">
+                <a:rPr sz="900">
                   <a:solidFill>
                     <a:srgbClr val="000000">
                       <a:alpha val="100000"/>
@@ -5469,23 +5469,23 @@
           </p:nvSpPr>
           <p:spPr>
             <a:xfrm>
-              <a:off x="1677821" y="3772270"/>
-              <a:ext cx="28468" cy="0"/>
+              <a:off x="1763067" y="3728774"/>
+              <a:ext cx="31631" cy="0"/>
             </a:xfrm>
             <a:custGeom>
               <a:avLst/>
               <a:pathLst>
-                <a:path w="28468" h="0">
+                <a:path w="31631" h="0">
                   <a:moveTo>
                     <a:pt x="0" y="0"/>
                   </a:moveTo>
                   <a:lnTo>
-                    <a:pt x="28468" y="0"/>
+                    <a:pt x="31631" y="0"/>
                   </a:lnTo>
                 </a:path>
               </a:pathLst>
             </a:custGeom>
-            <a:ln w="11086" cap="flat">
+            <a:ln w="12318" cap="flat">
               <a:solidFill>
                 <a:srgbClr val="333333">
                   <a:alpha val="100000"/>
@@ -5509,23 +5509,23 @@
           </p:nvSpPr>
           <p:spPr>
             <a:xfrm>
-              <a:off x="1677821" y="3579125"/>
-              <a:ext cx="28468" cy="0"/>
+              <a:off x="1763067" y="3538608"/>
+              <a:ext cx="31631" cy="0"/>
             </a:xfrm>
             <a:custGeom>
               <a:avLst/>
               <a:pathLst>
-                <a:path w="28468" h="0">
+                <a:path w="31631" h="0">
                   <a:moveTo>
                     <a:pt x="0" y="0"/>
                   </a:moveTo>
                   <a:lnTo>
-                    <a:pt x="28468" y="0"/>
+                    <a:pt x="31631" y="0"/>
                   </a:lnTo>
                 </a:path>
               </a:pathLst>
             </a:custGeom>
-            <a:ln w="11086" cap="flat">
+            <a:ln w="12318" cap="flat">
               <a:solidFill>
                 <a:srgbClr val="333333">
                   <a:alpha val="100000"/>
@@ -5549,23 +5549,23 @@
           </p:nvSpPr>
           <p:spPr>
             <a:xfrm>
-              <a:off x="1677821" y="3385980"/>
-              <a:ext cx="28468" cy="0"/>
+              <a:off x="1763067" y="3348443"/>
+              <a:ext cx="31631" cy="0"/>
             </a:xfrm>
             <a:custGeom>
               <a:avLst/>
               <a:pathLst>
-                <a:path w="28468" h="0">
+                <a:path w="31631" h="0">
                   <a:moveTo>
                     <a:pt x="0" y="0"/>
                   </a:moveTo>
                   <a:lnTo>
-                    <a:pt x="28468" y="0"/>
+                    <a:pt x="31631" y="0"/>
                   </a:lnTo>
                 </a:path>
               </a:pathLst>
             </a:custGeom>
-            <a:ln w="11086" cap="flat">
+            <a:ln w="12318" cap="flat">
               <a:solidFill>
                 <a:srgbClr val="333333">
                   <a:alpha val="100000"/>
@@ -5589,23 +5589,23 @@
           </p:nvSpPr>
           <p:spPr>
             <a:xfrm>
-              <a:off x="1677821" y="3192836"/>
-              <a:ext cx="28468" cy="0"/>
+              <a:off x="1763067" y="3158277"/>
+              <a:ext cx="31631" cy="0"/>
             </a:xfrm>
             <a:custGeom>
               <a:avLst/>
               <a:pathLst>
-                <a:path w="28468" h="0">
+                <a:path w="31631" h="0">
                   <a:moveTo>
                     <a:pt x="0" y="0"/>
                   </a:moveTo>
                   <a:lnTo>
-                    <a:pt x="28468" y="0"/>
+                    <a:pt x="31631" y="0"/>
                   </a:lnTo>
                 </a:path>
               </a:pathLst>
             </a:custGeom>
-            <a:ln w="11086" cap="flat">
+            <a:ln w="12318" cap="flat">
               <a:solidFill>
                 <a:srgbClr val="333333">
                   <a:alpha val="100000"/>
@@ -5629,23 +5629,23 @@
           </p:nvSpPr>
           <p:spPr>
             <a:xfrm>
-              <a:off x="1677821" y="2999691"/>
-              <a:ext cx="28468" cy="0"/>
+              <a:off x="1763067" y="2968112"/>
+              <a:ext cx="31631" cy="0"/>
             </a:xfrm>
             <a:custGeom>
               <a:avLst/>
               <a:pathLst>
-                <a:path w="28468" h="0">
+                <a:path w="31631" h="0">
                   <a:moveTo>
                     <a:pt x="0" y="0"/>
                   </a:moveTo>
                   <a:lnTo>
-                    <a:pt x="28468" y="0"/>
+                    <a:pt x="31631" y="0"/>
                   </a:lnTo>
                 </a:path>
               </a:pathLst>
             </a:custGeom>
-            <a:ln w="11086" cap="flat">
+            <a:ln w="12318" cap="flat">
               <a:solidFill>
                 <a:srgbClr val="333333">
                   <a:alpha val="100000"/>
@@ -5669,23 +5669,23 @@
           </p:nvSpPr>
           <p:spPr>
             <a:xfrm>
-              <a:off x="1677821" y="2806546"/>
-              <a:ext cx="28468" cy="0"/>
+              <a:off x="1763067" y="2777946"/>
+              <a:ext cx="31631" cy="0"/>
             </a:xfrm>
             <a:custGeom>
               <a:avLst/>
               <a:pathLst>
-                <a:path w="28468" h="0">
+                <a:path w="31631" h="0">
                   <a:moveTo>
                     <a:pt x="0" y="0"/>
                   </a:moveTo>
                   <a:lnTo>
-                    <a:pt x="28468" y="0"/>
+                    <a:pt x="31631" y="0"/>
                   </a:lnTo>
                 </a:path>
               </a:pathLst>
             </a:custGeom>
-            <a:ln w="11086" cap="flat">
+            <a:ln w="12318" cap="flat">
               <a:solidFill>
                 <a:srgbClr val="333333">
                   <a:alpha val="100000"/>
@@ -5709,23 +5709,23 @@
           </p:nvSpPr>
           <p:spPr>
             <a:xfrm>
-              <a:off x="1677821" y="2613402"/>
-              <a:ext cx="28468" cy="0"/>
+              <a:off x="1763067" y="2587781"/>
+              <a:ext cx="31631" cy="0"/>
             </a:xfrm>
             <a:custGeom>
               <a:avLst/>
               <a:pathLst>
-                <a:path w="28468" h="0">
+                <a:path w="31631" h="0">
                   <a:moveTo>
                     <a:pt x="0" y="0"/>
                   </a:moveTo>
                   <a:lnTo>
-                    <a:pt x="28468" y="0"/>
+                    <a:pt x="31631" y="0"/>
                   </a:lnTo>
                 </a:path>
               </a:pathLst>
             </a:custGeom>
-            <a:ln w="11086" cap="flat">
+            <a:ln w="12318" cap="flat">
               <a:solidFill>
                 <a:srgbClr val="333333">
                   <a:alpha val="100000"/>
@@ -5749,23 +5749,23 @@
           </p:nvSpPr>
           <p:spPr>
             <a:xfrm>
-              <a:off x="1677821" y="2420257"/>
-              <a:ext cx="28468" cy="0"/>
+              <a:off x="1763067" y="2397615"/>
+              <a:ext cx="31631" cy="0"/>
             </a:xfrm>
             <a:custGeom>
               <a:avLst/>
               <a:pathLst>
-                <a:path w="28468" h="0">
+                <a:path w="31631" h="0">
                   <a:moveTo>
                     <a:pt x="0" y="0"/>
                   </a:moveTo>
                   <a:lnTo>
-                    <a:pt x="28468" y="0"/>
+                    <a:pt x="31631" y="0"/>
                   </a:lnTo>
                 </a:path>
               </a:pathLst>
             </a:custGeom>
-            <a:ln w="11086" cap="flat">
+            <a:ln w="12318" cap="flat">
               <a:solidFill>
                 <a:srgbClr val="333333">
                   <a:alpha val="100000"/>
@@ -5789,23 +5789,23 @@
           </p:nvSpPr>
           <p:spPr>
             <a:xfrm>
-              <a:off x="1677821" y="2227112"/>
-              <a:ext cx="28468" cy="0"/>
+              <a:off x="1763067" y="2207450"/>
+              <a:ext cx="31631" cy="0"/>
             </a:xfrm>
             <a:custGeom>
               <a:avLst/>
               <a:pathLst>
-                <a:path w="28468" h="0">
+                <a:path w="31631" h="0">
                   <a:moveTo>
                     <a:pt x="0" y="0"/>
                   </a:moveTo>
                   <a:lnTo>
-                    <a:pt x="28468" y="0"/>
+                    <a:pt x="31631" y="0"/>
                   </a:lnTo>
                 </a:path>
               </a:pathLst>
             </a:custGeom>
-            <a:ln w="11086" cap="flat">
+            <a:ln w="12318" cap="flat">
               <a:solidFill>
                 <a:srgbClr val="333333">
                   <a:alpha val="100000"/>
@@ -5829,23 +5829,23 @@
           </p:nvSpPr>
           <p:spPr>
             <a:xfrm>
-              <a:off x="1677821" y="2033968"/>
-              <a:ext cx="28468" cy="0"/>
+              <a:off x="1763067" y="2017284"/>
+              <a:ext cx="31631" cy="0"/>
             </a:xfrm>
             <a:custGeom>
               <a:avLst/>
               <a:pathLst>
-                <a:path w="28468" h="0">
+                <a:path w="31631" h="0">
                   <a:moveTo>
                     <a:pt x="0" y="0"/>
                   </a:moveTo>
                   <a:lnTo>
-                    <a:pt x="28468" y="0"/>
+                    <a:pt x="31631" y="0"/>
                   </a:lnTo>
                 </a:path>
               </a:pathLst>
             </a:custGeom>
-            <a:ln w="11086" cap="flat">
+            <a:ln w="12318" cap="flat">
               <a:solidFill>
                 <a:srgbClr val="333333">
                   <a:alpha val="100000"/>
@@ -5869,23 +5869,23 @@
           </p:nvSpPr>
           <p:spPr>
             <a:xfrm>
-              <a:off x="1677821" y="1840823"/>
-              <a:ext cx="28468" cy="0"/>
+              <a:off x="1763067" y="1827119"/>
+              <a:ext cx="31631" cy="0"/>
             </a:xfrm>
             <a:custGeom>
               <a:avLst/>
               <a:pathLst>
-                <a:path w="28468" h="0">
+                <a:path w="31631" h="0">
                   <a:moveTo>
                     <a:pt x="0" y="0"/>
                   </a:moveTo>
                   <a:lnTo>
-                    <a:pt x="28468" y="0"/>
+                    <a:pt x="31631" y="0"/>
                   </a:lnTo>
                 </a:path>
               </a:pathLst>
             </a:custGeom>
-            <a:ln w="11086" cap="flat">
+            <a:ln w="12318" cap="flat">
               <a:solidFill>
                 <a:srgbClr val="333333">
                   <a:alpha val="100000"/>
@@ -5909,23 +5909,23 @@
           </p:nvSpPr>
           <p:spPr>
             <a:xfrm>
-              <a:off x="1677821" y="1647678"/>
-              <a:ext cx="28468" cy="0"/>
+              <a:off x="1763067" y="1636953"/>
+              <a:ext cx="31631" cy="0"/>
             </a:xfrm>
             <a:custGeom>
               <a:avLst/>
               <a:pathLst>
-                <a:path w="28468" h="0">
+                <a:path w="31631" h="0">
                   <a:moveTo>
                     <a:pt x="0" y="0"/>
                   </a:moveTo>
                   <a:lnTo>
-                    <a:pt x="28468" y="0"/>
+                    <a:pt x="31631" y="0"/>
                   </a:lnTo>
                 </a:path>
               </a:pathLst>
             </a:custGeom>
-            <a:ln w="11086" cap="flat">
+            <a:ln w="12318" cap="flat">
               <a:solidFill>
                 <a:srgbClr val="333333">
                   <a:alpha val="100000"/>
@@ -5949,23 +5949,23 @@
           </p:nvSpPr>
           <p:spPr>
             <a:xfrm>
-              <a:off x="1677821" y="1454533"/>
-              <a:ext cx="28468" cy="0"/>
+              <a:off x="1763067" y="1446787"/>
+              <a:ext cx="31631" cy="0"/>
             </a:xfrm>
             <a:custGeom>
               <a:avLst/>
               <a:pathLst>
-                <a:path w="28468" h="0">
+                <a:path w="31631" h="0">
                   <a:moveTo>
                     <a:pt x="0" y="0"/>
                   </a:moveTo>
                   <a:lnTo>
-                    <a:pt x="28468" y="0"/>
+                    <a:pt x="31631" y="0"/>
                   </a:lnTo>
                 </a:path>
               </a:pathLst>
             </a:custGeom>
-            <a:ln w="11086" cap="flat">
+            <a:ln w="12318" cap="flat">
               <a:solidFill>
                 <a:srgbClr val="333333">
                   <a:alpha val="100000"/>
@@ -5989,23 +5989,23 @@
           </p:nvSpPr>
           <p:spPr>
             <a:xfrm>
-              <a:off x="1677821" y="1261389"/>
-              <a:ext cx="28468" cy="0"/>
+              <a:off x="1763067" y="1256622"/>
+              <a:ext cx="31631" cy="0"/>
             </a:xfrm>
             <a:custGeom>
               <a:avLst/>
               <a:pathLst>
-                <a:path w="28468" h="0">
+                <a:path w="31631" h="0">
                   <a:moveTo>
                     <a:pt x="0" y="0"/>
                   </a:moveTo>
                   <a:lnTo>
-                    <a:pt x="28468" y="0"/>
+                    <a:pt x="31631" y="0"/>
                   </a:lnTo>
                 </a:path>
               </a:pathLst>
             </a:custGeom>
-            <a:ln w="11086" cap="flat">
+            <a:ln w="12318" cap="flat">
               <a:solidFill>
                 <a:srgbClr val="333333">
                   <a:alpha val="100000"/>
@@ -6029,23 +6029,23 @@
           </p:nvSpPr>
           <p:spPr>
             <a:xfrm>
-              <a:off x="1677821" y="1068244"/>
-              <a:ext cx="28468" cy="0"/>
+              <a:off x="1763067" y="1066456"/>
+              <a:ext cx="31631" cy="0"/>
             </a:xfrm>
             <a:custGeom>
               <a:avLst/>
               <a:pathLst>
-                <a:path w="28468" h="0">
+                <a:path w="31631" h="0">
                   <a:moveTo>
                     <a:pt x="0" y="0"/>
                   </a:moveTo>
                   <a:lnTo>
-                    <a:pt x="28468" y="0"/>
+                    <a:pt x="31631" y="0"/>
                   </a:lnTo>
                 </a:path>
               </a:pathLst>
             </a:custGeom>
-            <a:ln w="11086" cap="flat">
+            <a:ln w="12318" cap="flat">
               <a:solidFill>
                 <a:srgbClr val="333333">
                   <a:alpha val="100000"/>
@@ -6069,23 +6069,23 @@
           </p:nvSpPr>
           <p:spPr>
             <a:xfrm>
-              <a:off x="1706289" y="3888157"/>
-              <a:ext cx="2397500" cy="0"/>
+              <a:off x="1794699" y="3842873"/>
+              <a:ext cx="2309090" cy="0"/>
             </a:xfrm>
             <a:custGeom>
               <a:avLst/>
               <a:pathLst>
-                <a:path w="2397500" h="0">
+                <a:path w="2309090" h="0">
                   <a:moveTo>
                     <a:pt x="0" y="0"/>
                   </a:moveTo>
                   <a:lnTo>
-                    <a:pt x="2397500" y="0"/>
+                    <a:pt x="2309090" y="0"/>
                   </a:lnTo>
                 </a:path>
               </a:pathLst>
             </a:custGeom>
-            <a:ln w="11086" cap="flat">
+            <a:ln w="12318" cap="flat">
               <a:solidFill>
                 <a:srgbClr val="000000">
                   <a:alpha val="100000"/>
@@ -6109,15 +6109,15 @@
           </p:nvSpPr>
           <p:spPr>
             <a:xfrm>
-              <a:off x="1838428" y="3888157"/>
-              <a:ext cx="0" cy="28468"/>
+              <a:off x="1921965" y="3842873"/>
+              <a:ext cx="0" cy="31631"/>
             </a:xfrm>
             <a:custGeom>
               <a:avLst/>
               <a:pathLst>
-                <a:path w="0" h="28468">
+                <a:path w="0" h="31631">
                   <a:moveTo>
-                    <a:pt x="0" y="28468"/>
+                    <a:pt x="0" y="31631"/>
                   </a:moveTo>
                   <a:lnTo>
                     <a:pt x="0" y="0"/>
@@ -6125,7 +6125,7 @@
                 </a:path>
               </a:pathLst>
             </a:custGeom>
-            <a:ln w="11086" cap="flat">
+            <a:ln w="12318" cap="flat">
               <a:solidFill>
                 <a:srgbClr val="333333">
                   <a:alpha val="100000"/>
@@ -6149,15 +6149,15 @@
           </p:nvSpPr>
           <p:spPr>
             <a:xfrm>
-              <a:off x="2384126" y="3888157"/>
-              <a:ext cx="0" cy="28468"/>
+              <a:off x="2447540" y="3842873"/>
+              <a:ext cx="0" cy="31631"/>
             </a:xfrm>
             <a:custGeom>
               <a:avLst/>
               <a:pathLst>
-                <a:path w="0" h="28468">
+                <a:path w="0" h="31631">
                   <a:moveTo>
-                    <a:pt x="0" y="28468"/>
+                    <a:pt x="0" y="31631"/>
                   </a:moveTo>
                   <a:lnTo>
                     <a:pt x="0" y="0"/>
@@ -6165,7 +6165,7 @@
                 </a:path>
               </a:pathLst>
             </a:custGeom>
-            <a:ln w="11086" cap="flat">
+            <a:ln w="12318" cap="flat">
               <a:solidFill>
                 <a:srgbClr val="333333">
                   <a:alpha val="100000"/>
@@ -6189,15 +6189,15 @@
           </p:nvSpPr>
           <p:spPr>
             <a:xfrm>
-              <a:off x="2929825" y="3888157"/>
-              <a:ext cx="0" cy="28468"/>
+              <a:off x="2973116" y="3842873"/>
+              <a:ext cx="0" cy="31631"/>
             </a:xfrm>
             <a:custGeom>
               <a:avLst/>
               <a:pathLst>
-                <a:path w="0" h="28468">
+                <a:path w="0" h="31631">
                   <a:moveTo>
-                    <a:pt x="0" y="28468"/>
+                    <a:pt x="0" y="31631"/>
                   </a:moveTo>
                   <a:lnTo>
                     <a:pt x="0" y="0"/>
@@ -6205,7 +6205,7 @@
                 </a:path>
               </a:pathLst>
             </a:custGeom>
-            <a:ln w="11086" cap="flat">
+            <a:ln w="12318" cap="flat">
               <a:solidFill>
                 <a:srgbClr val="333333">
                   <a:alpha val="100000"/>
@@ -6229,15 +6229,15 @@
           </p:nvSpPr>
           <p:spPr>
             <a:xfrm>
-              <a:off x="3475523" y="3888157"/>
-              <a:ext cx="0" cy="28468"/>
+              <a:off x="3498691" y="3842873"/>
+              <a:ext cx="0" cy="31631"/>
             </a:xfrm>
             <a:custGeom>
               <a:avLst/>
               <a:pathLst>
-                <a:path w="0" h="28468">
+                <a:path w="0" h="31631">
                   <a:moveTo>
-                    <a:pt x="0" y="28468"/>
+                    <a:pt x="0" y="31631"/>
                   </a:moveTo>
                   <a:lnTo>
                     <a:pt x="0" y="0"/>
@@ -6245,7 +6245,7 @@
                 </a:path>
               </a:pathLst>
             </a:custGeom>
-            <a:ln w="11086" cap="flat">
+            <a:ln w="12318" cap="flat">
               <a:solidFill>
                 <a:srgbClr val="333333">
                   <a:alpha val="100000"/>
@@ -6269,15 +6269,15 @@
           </p:nvSpPr>
           <p:spPr>
             <a:xfrm>
-              <a:off x="4021222" y="3888157"/>
-              <a:ext cx="0" cy="28468"/>
+              <a:off x="4024267" y="3842873"/>
+              <a:ext cx="0" cy="31631"/>
             </a:xfrm>
             <a:custGeom>
               <a:avLst/>
               <a:pathLst>
-                <a:path w="0" h="28468">
+                <a:path w="0" h="31631">
                   <a:moveTo>
-                    <a:pt x="0" y="28468"/>
+                    <a:pt x="0" y="31631"/>
                   </a:moveTo>
                   <a:lnTo>
                     <a:pt x="0" y="0"/>
@@ -6285,7 +6285,7 @@
                 </a:path>
               </a:pathLst>
             </a:custGeom>
-            <a:ln w="11086" cap="flat">
+            <a:ln w="12318" cap="flat">
               <a:solidFill>
                 <a:srgbClr val="333333">
                   <a:alpha val="100000"/>
@@ -6309,8 +6309,8 @@
           </p:nvSpPr>
           <p:spPr>
             <a:xfrm>
-              <a:off x="1722619" y="3939400"/>
-              <a:ext cx="231617" cy="72877"/>
+              <a:off x="1791754" y="3899809"/>
+              <a:ext cx="260421" cy="82021"/>
             </a:xfrm>
             <a:prstGeom prst="rect">
               <a:avLst/>
@@ -6323,7 +6323,7 @@
             <a:p>
               <a:pPr algn="l" marL="0" marR="0" indent="0">
                 <a:lnSpc>
-                  <a:spcPts val="800"/>
+                  <a:spcPts val="900"/>
                 </a:lnSpc>
                 <a:spcBef>
                   <a:spcPts val="0"/>
@@ -6333,7 +6333,7 @@
                 </a:spcAft>
               </a:pPr>
               <a:r>
-                <a:rPr sz="800">
+                <a:rPr sz="900">
                   <a:solidFill>
                     <a:srgbClr val="000000">
                       <a:alpha val="100000"/>
@@ -6355,8 +6355,8 @@
           </p:nvSpPr>
           <p:spPr>
             <a:xfrm>
-              <a:off x="2268317" y="3939400"/>
-              <a:ext cx="231617" cy="72877"/>
+              <a:off x="2317330" y="3899809"/>
+              <a:ext cx="260421" cy="82021"/>
             </a:xfrm>
             <a:prstGeom prst="rect">
               <a:avLst/>
@@ -6369,7 +6369,7 @@
             <a:p>
               <a:pPr algn="l" marL="0" marR="0" indent="0">
                 <a:lnSpc>
-                  <a:spcPts val="800"/>
+                  <a:spcPts val="900"/>
                 </a:lnSpc>
                 <a:spcBef>
                   <a:spcPts val="0"/>
@@ -6379,7 +6379,7 @@
                 </a:spcAft>
               </a:pPr>
               <a:r>
-                <a:rPr sz="800">
+                <a:rPr sz="900">
                   <a:solidFill>
                     <a:srgbClr val="000000">
                       <a:alpha val="100000"/>
@@ -6401,8 +6401,8 @@
           </p:nvSpPr>
           <p:spPr>
             <a:xfrm>
-              <a:off x="2830932" y="3939400"/>
-              <a:ext cx="197784" cy="72877"/>
+              <a:off x="2861925" y="3899809"/>
+              <a:ext cx="222382" cy="82021"/>
             </a:xfrm>
             <a:prstGeom prst="rect">
               <a:avLst/>
@@ -6415,7 +6415,7 @@
             <a:p>
               <a:pPr algn="l" marL="0" marR="0" indent="0">
                 <a:lnSpc>
-                  <a:spcPts val="800"/>
+                  <a:spcPts val="900"/>
                 </a:lnSpc>
                 <a:spcBef>
                   <a:spcPts val="0"/>
@@ -6425,7 +6425,7 @@
                 </a:spcAft>
               </a:pPr>
               <a:r>
-                <a:rPr sz="800">
+                <a:rPr sz="900">
                   <a:solidFill>
                     <a:srgbClr val="000000">
                       <a:alpha val="100000"/>
@@ -6447,8 +6447,8 @@
           </p:nvSpPr>
           <p:spPr>
             <a:xfrm>
-              <a:off x="3376631" y="3939400"/>
-              <a:ext cx="197784" cy="72877"/>
+              <a:off x="3387500" y="3899809"/>
+              <a:ext cx="222382" cy="82021"/>
             </a:xfrm>
             <a:prstGeom prst="rect">
               <a:avLst/>
@@ -6461,7 +6461,7 @@
             <a:p>
               <a:pPr algn="l" marL="0" marR="0" indent="0">
                 <a:lnSpc>
-                  <a:spcPts val="800"/>
+                  <a:spcPts val="900"/>
                 </a:lnSpc>
                 <a:spcBef>
                   <a:spcPts val="0"/>
@@ -6471,7 +6471,7 @@
                 </a:spcAft>
               </a:pPr>
               <a:r>
-                <a:rPr sz="800">
+                <a:rPr sz="900">
                   <a:solidFill>
                     <a:srgbClr val="000000">
                       <a:alpha val="100000"/>
@@ -6493,8 +6493,8 @@
           </p:nvSpPr>
           <p:spPr>
             <a:xfrm>
-              <a:off x="3922330" y="3939400"/>
-              <a:ext cx="197784" cy="72877"/>
+              <a:off x="3913076" y="3899809"/>
+              <a:ext cx="222382" cy="82021"/>
             </a:xfrm>
             <a:prstGeom prst="rect">
               <a:avLst/>
@@ -6507,7 +6507,7 @@
             <a:p>
               <a:pPr algn="l" marL="0" marR="0" indent="0">
                 <a:lnSpc>
-                  <a:spcPts val="800"/>
+                  <a:spcPts val="900"/>
                 </a:lnSpc>
                 <a:spcBef>
                   <a:spcPts val="0"/>
@@ -6517,7 +6517,7 @@
                 </a:spcAft>
               </a:pPr>
               <a:r>
-                <a:rPr sz="800">
+                <a:rPr sz="900">
                   <a:solidFill>
                     <a:srgbClr val="000000">
                       <a:alpha val="100000"/>
@@ -6539,8 +6539,126 @@
           </p:nvSpPr>
           <p:spPr>
             <a:xfrm>
-              <a:off x="1927683" y="4097036"/>
-              <a:ext cx="1954712" cy="91165"/>
+              <a:off x="1873864" y="4075879"/>
+              <a:ext cx="2150760" cy="100218"/>
+            </a:xfrm>
+            <a:prstGeom prst="rect">
+              <a:avLst/>
+            </a:prstGeom>
+            <a:noFill/>
+          </p:spPr>
+          <p:txBody>
+            <a:bodyPr lIns="0" rIns="0" tIns="0" bIns="0" anchorCtr="1" anchor="ctr" wrap="none"/>
+            <a:lstStyle/>
+            <a:p>
+              <a:pPr algn="l" marL="0" marR="0" indent="0">
+                <a:lnSpc>
+                  <a:spcPts val="1100"/>
+                </a:lnSpc>
+                <a:spcBef>
+                  <a:spcPts val="0"/>
+                </a:spcBef>
+                <a:spcAft>
+                  <a:spcPts val="0"/>
+                </a:spcAft>
+              </a:pPr>
+              <a:r>
+                <a:rPr sz="1100">
+                  <a:solidFill>
+                    <a:srgbClr val="000000">
+                      <a:alpha val="100000"/>
+                    </a:srgbClr>
+                  </a:solidFill>
+                  <a:latin typeface="Helvetica"/>
+                  <a:cs typeface="Helvetica"/>
+                </a:rPr>
+                <a:t>Regression coefficients (Richness)</a:t>
+              </a:r>
+            </a:p>
+          </p:txBody>
+        </p:sp>
+        <p:sp>
+          <p:nvSpPr>
+            <p:cNvPr id="112" name="tx111"/>
+            <p:cNvSpPr/>
+            <p:nvPr/>
+          </p:nvSpPr>
+          <p:spPr>
+            <a:xfrm rot="-5400000">
+              <a:off x="844538" y="2347506"/>
+              <a:ext cx="279349" cy="100218"/>
+            </a:xfrm>
+            <a:prstGeom prst="rect">
+              <a:avLst/>
+            </a:prstGeom>
+            <a:noFill/>
+          </p:spPr>
+          <p:txBody>
+            <a:bodyPr lIns="0" rIns="0" tIns="0" bIns="0" anchorCtr="1" anchor="ctr" wrap="none"/>
+            <a:lstStyle/>
+            <a:p>
+              <a:pPr algn="l" marL="0" marR="0" indent="0">
+                <a:lnSpc>
+                  <a:spcPts val="1100"/>
+                </a:lnSpc>
+                <a:spcBef>
+                  <a:spcPts val="0"/>
+                </a:spcBef>
+                <a:spcAft>
+                  <a:spcPts val="0"/>
+                </a:spcAft>
+              </a:pPr>
+              <a:r>
+                <a:rPr sz="1100">
+                  <a:solidFill>
+                    <a:srgbClr val="000000">
+                      <a:alpha val="100000"/>
+                    </a:srgbClr>
+                  </a:solidFill>
+                  <a:latin typeface="Helvetica"/>
+                  <a:cs typeface="Helvetica"/>
+                </a:rPr>
+                <a:t>Trait</a:t>
+              </a:r>
+            </a:p>
+          </p:txBody>
+        </p:sp>
+        <p:sp>
+          <p:nvSpPr>
+            <p:cNvPr id="113" name="rc112"/>
+            <p:cNvSpPr/>
+            <p:nvPr/>
+          </p:nvSpPr>
+          <p:spPr>
+            <a:xfrm>
+              <a:off x="1556366" y="4296442"/>
+              <a:ext cx="2598033" cy="180000"/>
+            </a:xfrm>
+            <a:prstGeom prst="rect">
+              <a:avLst/>
+            </a:prstGeom>
+            <a:solidFill>
+              <a:srgbClr val="FFFFFF">
+                <a:alpha val="100000"/>
+              </a:srgbClr>
+            </a:solidFill>
+          </p:spPr>
+          <p:txBody>
+            <a:bodyPr/>
+            <a:lstStyle/>
+            <a:p/>
+          </p:txBody>
+        </p:sp>
+        <p:sp>
+          <p:nvSpPr>
+            <p:cNvPr id="114" name="tx113"/>
+            <p:cNvSpPr/>
+            <p:nvPr/>
+          </p:nvSpPr>
+          <p:spPr>
+            <a:xfrm>
+              <a:off x="1556366" y="4340722"/>
+              <a:ext cx="825703" cy="91440"/>
             </a:xfrm>
             <a:prstGeom prst="rect">
               <a:avLst/>
@@ -6563,7 +6681,7 @@
                 </a:spcAft>
               </a:pPr>
               <a:r>
-                <a:rPr sz="1000">
+                <a:rPr sz="1000" b="1">
                   <a:solidFill>
                     <a:srgbClr val="000000">
                       <a:alpha val="100000"/>
@@ -6572,67 +6690,21 @@
                   <a:latin typeface="Helvetica"/>
                   <a:cs typeface="Helvetica"/>
                 </a:rPr>
-                <a:t>Regression coefficients (Richness)</a:t>
+                <a:t>Compartment</a:t>
               </a:r>
             </a:p>
           </p:txBody>
         </p:sp>
         <p:sp>
           <p:nvSpPr>
-            <p:cNvPr id="112" name="tx111"/>
-            <p:cNvSpPr/>
-            <p:nvPr/>
-          </p:nvSpPr>
-          <p:spPr>
-            <a:xfrm rot="-5400000">
-              <a:off x="855419" y="2374674"/>
-              <a:ext cx="254020" cy="91165"/>
-            </a:xfrm>
-            <a:prstGeom prst="rect">
-              <a:avLst/>
-            </a:prstGeom>
-            <a:noFill/>
-          </p:spPr>
-          <p:txBody>
-            <a:bodyPr lIns="0" rIns="0" tIns="0" bIns="0" anchorCtr="1" anchor="ctr" wrap="none"/>
-            <a:lstStyle/>
-            <a:p>
-              <a:pPr algn="l" marL="0" marR="0" indent="0">
-                <a:lnSpc>
-                  <a:spcPts val="1000"/>
-                </a:lnSpc>
-                <a:spcBef>
-                  <a:spcPts val="0"/>
-                </a:spcBef>
-                <a:spcAft>
-                  <a:spcPts val="0"/>
-                </a:spcAft>
-              </a:pPr>
-              <a:r>
-                <a:rPr sz="1000">
-                  <a:solidFill>
-                    <a:srgbClr val="000000">
-                      <a:alpha val="100000"/>
-                    </a:srgbClr>
-                  </a:solidFill>
-                  <a:latin typeface="Helvetica"/>
-                  <a:cs typeface="Helvetica"/>
-                </a:rPr>
-                <a:t>Trait</a:t>
-              </a:r>
-            </a:p>
-          </p:txBody>
-        </p:sp>
-        <p:sp>
-          <p:nvSpPr>
-            <p:cNvPr id="113" name="rc112"/>
-            <p:cNvSpPr/>
-            <p:nvPr/>
-          </p:nvSpPr>
-          <p:spPr>
-            <a:xfrm>
-              <a:off x="1640896" y="4296442"/>
-              <a:ext cx="2513503" cy="180000"/>
+            <p:cNvPr id="115" name="rc114"/>
+            <p:cNvSpPr/>
+            <p:nvPr/>
+          </p:nvSpPr>
+          <p:spPr>
+            <a:xfrm>
+              <a:off x="2445332" y="4296442"/>
+              <a:ext cx="179999" cy="180000"/>
             </a:xfrm>
             <a:prstGeom prst="rect">
               <a:avLst/>
@@ -6651,14 +6723,180 @@
         </p:sp>
         <p:sp>
           <p:nvSpPr>
-            <p:cNvPr id="114" name="tx113"/>
-            <p:cNvSpPr/>
-            <p:nvPr/>
-          </p:nvSpPr>
-          <p:spPr>
-            <a:xfrm>
-              <a:off x="1640896" y="4345294"/>
-              <a:ext cx="742950" cy="82296"/>
+            <p:cNvPr id="116" name="pl115"/>
+            <p:cNvSpPr/>
+            <p:nvPr/>
+          </p:nvSpPr>
+          <p:spPr>
+            <a:xfrm>
+              <a:off x="2463332" y="4386442"/>
+              <a:ext cx="144000" cy="0"/>
+            </a:xfrm>
+            <a:custGeom>
+              <a:avLst/>
+              <a:pathLst>
+                <a:path w="144000" h="0">
+                  <a:moveTo>
+                    <a:pt x="0" y="0"/>
+                  </a:moveTo>
+                  <a:lnTo>
+                    <a:pt x="144000" y="0"/>
+                  </a:lnTo>
+                </a:path>
+              </a:pathLst>
+            </a:custGeom>
+            <a:ln w="21681" cap="flat">
+              <a:solidFill>
+                <a:srgbClr val="2F7F6F">
+                  <a:alpha val="100000"/>
+                </a:srgbClr>
+              </a:solidFill>
+              <a:prstDash val="solid"/>
+              <a:round/>
+            </a:ln>
+          </p:spPr>
+          <p:txBody>
+            <a:bodyPr/>
+            <a:lstStyle/>
+            <a:p/>
+          </p:txBody>
+        </p:sp>
+        <p:sp>
+          <p:nvSpPr>
+            <p:cNvPr id="117" name="pt116"/>
+            <p:cNvSpPr/>
+            <p:nvPr/>
+          </p:nvSpPr>
+          <p:spPr>
+            <a:xfrm>
+              <a:off x="2483880" y="4334990"/>
+              <a:ext cx="102903" cy="102903"/>
+            </a:xfrm>
+            <a:prstGeom prst="ellipse">
+              <a:avLst/>
+            </a:prstGeom>
+            <a:ln w="21600" cap="rnd">
+              <a:solidFill>
+                <a:srgbClr val="2F7F6F">
+                  <a:alpha val="100000"/>
+                </a:srgbClr>
+              </a:solidFill>
+              <a:prstDash val="solid"/>
+              <a:round/>
+            </a:ln>
+          </p:spPr>
+          <p:txBody>
+            <a:bodyPr/>
+            <a:lstStyle/>
+            <a:p/>
+          </p:txBody>
+        </p:sp>
+        <p:sp>
+          <p:nvSpPr>
+            <p:cNvPr id="118" name="rc117"/>
+            <p:cNvSpPr/>
+            <p:nvPr/>
+          </p:nvSpPr>
+          <p:spPr>
+            <a:xfrm>
+              <a:off x="3431713" y="4296442"/>
+              <a:ext cx="179999" cy="180000"/>
+            </a:xfrm>
+            <a:prstGeom prst="rect">
+              <a:avLst/>
+            </a:prstGeom>
+            <a:solidFill>
+              <a:srgbClr val="FFFFFF">
+                <a:alpha val="100000"/>
+              </a:srgbClr>
+            </a:solidFill>
+          </p:spPr>
+          <p:txBody>
+            <a:bodyPr/>
+            <a:lstStyle/>
+            <a:p/>
+          </p:txBody>
+        </p:sp>
+        <p:sp>
+          <p:nvSpPr>
+            <p:cNvPr id="119" name="pl118"/>
+            <p:cNvSpPr/>
+            <p:nvPr/>
+          </p:nvSpPr>
+          <p:spPr>
+            <a:xfrm>
+              <a:off x="3449713" y="4386442"/>
+              <a:ext cx="144000" cy="0"/>
+            </a:xfrm>
+            <a:custGeom>
+              <a:avLst/>
+              <a:pathLst>
+                <a:path w="144000" h="0">
+                  <a:moveTo>
+                    <a:pt x="0" y="0"/>
+                  </a:moveTo>
+                  <a:lnTo>
+                    <a:pt x="144000" y="0"/>
+                  </a:lnTo>
+                </a:path>
+              </a:pathLst>
+            </a:custGeom>
+            <a:ln w="21681" cap="flat">
+              <a:solidFill>
+                <a:srgbClr val="9C6B2F">
+                  <a:alpha val="100000"/>
+                </a:srgbClr>
+              </a:solidFill>
+              <a:prstDash val="solid"/>
+              <a:round/>
+            </a:ln>
+          </p:spPr>
+          <p:txBody>
+            <a:bodyPr/>
+            <a:lstStyle/>
+            <a:p/>
+          </p:txBody>
+        </p:sp>
+        <p:sp>
+          <p:nvSpPr>
+            <p:cNvPr id="120" name="pt119"/>
+            <p:cNvSpPr/>
+            <p:nvPr/>
+          </p:nvSpPr>
+          <p:spPr>
+            <a:xfrm>
+              <a:off x="3470262" y="4334990"/>
+              <a:ext cx="102903" cy="102903"/>
+            </a:xfrm>
+            <a:prstGeom prst="ellipse">
+              <a:avLst/>
+            </a:prstGeom>
+            <a:ln w="21600" cap="rnd">
+              <a:solidFill>
+                <a:srgbClr val="9C6B2F">
+                  <a:alpha val="100000"/>
+                </a:srgbClr>
+              </a:solidFill>
+              <a:prstDash val="solid"/>
+              <a:round/>
+            </a:ln>
+          </p:spPr>
+          <p:txBody>
+            <a:bodyPr/>
+            <a:lstStyle/>
+            <a:p/>
+          </p:txBody>
+        </p:sp>
+        <p:sp>
+          <p:nvSpPr>
+            <p:cNvPr id="121" name="tx120"/>
+            <p:cNvSpPr/>
+            <p:nvPr/>
+          </p:nvSpPr>
+          <p:spPr>
+            <a:xfrm>
+              <a:off x="2688594" y="4345431"/>
+              <a:ext cx="679856" cy="82021"/>
             </a:xfrm>
             <a:prstGeom prst="rect">
               <a:avLst/>
@@ -6681,245 +6919,7 @@
                 </a:spcAft>
               </a:pPr>
               <a:r>
-                <a:rPr sz="900" b="1">
-                  <a:solidFill>
-                    <a:srgbClr val="000000">
-                      <a:alpha val="100000"/>
-                    </a:srgbClr>
-                  </a:solidFill>
-                  <a:latin typeface="Helvetica"/>
-                  <a:cs typeface="Helvetica"/>
-                </a:rPr>
-                <a:t>Compartment</a:t>
-              </a:r>
-            </a:p>
-          </p:txBody>
-        </p:sp>
-        <p:sp>
-          <p:nvSpPr>
-            <p:cNvPr id="115" name="rc114"/>
-            <p:cNvSpPr/>
-            <p:nvPr/>
-          </p:nvSpPr>
-          <p:spPr>
-            <a:xfrm>
-              <a:off x="2440783" y="4296442"/>
-              <a:ext cx="179999" cy="180000"/>
-            </a:xfrm>
-            <a:prstGeom prst="rect">
-              <a:avLst/>
-            </a:prstGeom>
-            <a:solidFill>
-              <a:srgbClr val="FFFFFF">
-                <a:alpha val="100000"/>
-              </a:srgbClr>
-            </a:solidFill>
-          </p:spPr>
-          <p:txBody>
-            <a:bodyPr/>
-            <a:lstStyle/>
-            <a:p/>
-          </p:txBody>
-        </p:sp>
-        <p:sp>
-          <p:nvSpPr>
-            <p:cNvPr id="116" name="pl115"/>
-            <p:cNvSpPr/>
-            <p:nvPr/>
-          </p:nvSpPr>
-          <p:spPr>
-            <a:xfrm>
-              <a:off x="2458783" y="4386442"/>
-              <a:ext cx="144000" cy="0"/>
-            </a:xfrm>
-            <a:custGeom>
-              <a:avLst/>
-              <a:pathLst>
-                <a:path w="144000" h="0">
-                  <a:moveTo>
-                    <a:pt x="0" y="0"/>
-                  </a:moveTo>
-                  <a:lnTo>
-                    <a:pt x="144000" y="0"/>
-                  </a:lnTo>
-                </a:path>
-              </a:pathLst>
-            </a:custGeom>
-            <a:ln w="21681" cap="flat">
-              <a:solidFill>
-                <a:srgbClr val="2F7F6F">
-                  <a:alpha val="100000"/>
-                </a:srgbClr>
-              </a:solidFill>
-              <a:prstDash val="solid"/>
-              <a:round/>
-            </a:ln>
-          </p:spPr>
-          <p:txBody>
-            <a:bodyPr/>
-            <a:lstStyle/>
-            <a:p/>
-          </p:txBody>
-        </p:sp>
-        <p:sp>
-          <p:nvSpPr>
-            <p:cNvPr id="117" name="pt116"/>
-            <p:cNvSpPr/>
-            <p:nvPr/>
-          </p:nvSpPr>
-          <p:spPr>
-            <a:xfrm>
-              <a:off x="2479331" y="4334990"/>
-              <a:ext cx="102903" cy="102903"/>
-            </a:xfrm>
-            <a:prstGeom prst="ellipse">
-              <a:avLst/>
-            </a:prstGeom>
-            <a:ln w="21600" cap="rnd">
-              <a:solidFill>
-                <a:srgbClr val="2F7F6F">
-                  <a:alpha val="100000"/>
-                </a:srgbClr>
-              </a:solidFill>
-              <a:prstDash val="solid"/>
-              <a:round/>
-            </a:ln>
-          </p:spPr>
-          <p:txBody>
-            <a:bodyPr/>
-            <a:lstStyle/>
-            <a:p/>
-          </p:txBody>
-        </p:sp>
-        <p:sp>
-          <p:nvSpPr>
-            <p:cNvPr id="118" name="rc117"/>
-            <p:cNvSpPr/>
-            <p:nvPr/>
-          </p:nvSpPr>
-          <p:spPr>
-            <a:xfrm>
-              <a:off x="3339166" y="4296442"/>
-              <a:ext cx="179999" cy="180000"/>
-            </a:xfrm>
-            <a:prstGeom prst="rect">
-              <a:avLst/>
-            </a:prstGeom>
-            <a:solidFill>
-              <a:srgbClr val="FFFFFF">
-                <a:alpha val="100000"/>
-              </a:srgbClr>
-            </a:solidFill>
-          </p:spPr>
-          <p:txBody>
-            <a:bodyPr/>
-            <a:lstStyle/>
-            <a:p/>
-          </p:txBody>
-        </p:sp>
-        <p:sp>
-          <p:nvSpPr>
-            <p:cNvPr id="119" name="pl118"/>
-            <p:cNvSpPr/>
-            <p:nvPr/>
-          </p:nvSpPr>
-          <p:spPr>
-            <a:xfrm>
-              <a:off x="3357166" y="4386442"/>
-              <a:ext cx="143999" cy="0"/>
-            </a:xfrm>
-            <a:custGeom>
-              <a:avLst/>
-              <a:pathLst>
-                <a:path w="143999" h="0">
-                  <a:moveTo>
-                    <a:pt x="0" y="0"/>
-                  </a:moveTo>
-                  <a:lnTo>
-                    <a:pt x="143999" y="0"/>
-                  </a:lnTo>
-                </a:path>
-              </a:pathLst>
-            </a:custGeom>
-            <a:ln w="21681" cap="flat">
-              <a:solidFill>
-                <a:srgbClr val="9C6B2F">
-                  <a:alpha val="100000"/>
-                </a:srgbClr>
-              </a:solidFill>
-              <a:prstDash val="solid"/>
-              <a:round/>
-            </a:ln>
-          </p:spPr>
-          <p:txBody>
-            <a:bodyPr/>
-            <a:lstStyle/>
-            <a:p/>
-          </p:txBody>
-        </p:sp>
-        <p:sp>
-          <p:nvSpPr>
-            <p:cNvPr id="120" name="pt119"/>
-            <p:cNvSpPr/>
-            <p:nvPr/>
-          </p:nvSpPr>
-          <p:spPr>
-            <a:xfrm>
-              <a:off x="3377714" y="4334990"/>
-              <a:ext cx="102903" cy="102903"/>
-            </a:xfrm>
-            <a:prstGeom prst="ellipse">
-              <a:avLst/>
-            </a:prstGeom>
-            <a:ln w="21600" cap="rnd">
-              <a:solidFill>
-                <a:srgbClr val="9C6B2F">
-                  <a:alpha val="100000"/>
-                </a:srgbClr>
-              </a:solidFill>
-              <a:prstDash val="solid"/>
-              <a:round/>
-            </a:ln>
-          </p:spPr>
-          <p:txBody>
-            <a:bodyPr/>
-            <a:lstStyle/>
-            <a:p/>
-          </p:txBody>
-        </p:sp>
-        <p:sp>
-          <p:nvSpPr>
-            <p:cNvPr id="121" name="tx120"/>
-            <p:cNvSpPr/>
-            <p:nvPr/>
-          </p:nvSpPr>
-          <p:spPr>
-            <a:xfrm>
-              <a:off x="2677719" y="4350003"/>
-              <a:ext cx="604509" cy="72877"/>
-            </a:xfrm>
-            <a:prstGeom prst="rect">
-              <a:avLst/>
-            </a:prstGeom>
-            <a:noFill/>
-          </p:spPr>
-          <p:txBody>
-            <a:bodyPr lIns="0" rIns="0" tIns="0" bIns="0" anchorCtr="1" anchor="ctr" wrap="none"/>
-            <a:lstStyle/>
-            <a:p>
-              <a:pPr algn="l" marL="0" marR="0" indent="0">
-                <a:lnSpc>
-                  <a:spcPts val="800"/>
-                </a:lnSpc>
-                <a:spcBef>
-                  <a:spcPts val="0"/>
-                </a:spcBef>
-                <a:spcAft>
-                  <a:spcPts val="0"/>
-                </a:spcAft>
-              </a:pPr>
-              <a:r>
-                <a:rPr sz="800">
+                <a:rPr sz="900">
                   <a:solidFill>
                     <a:srgbClr val="000000">
                       <a:alpha val="100000"/>
@@ -6941,8 +6941,8 @@
           </p:nvSpPr>
           <p:spPr>
             <a:xfrm>
-              <a:off x="3576102" y="4350003"/>
-              <a:ext cx="593079" cy="72877"/>
+              <a:off x="3674976" y="4345431"/>
+              <a:ext cx="667146" cy="82021"/>
             </a:xfrm>
             <a:prstGeom prst="rect">
               <a:avLst/>
@@ -6955,7 +6955,7 @@
             <a:p>
               <a:pPr algn="l" marL="0" marR="0" indent="0">
                 <a:lnSpc>
-                  <a:spcPts val="800"/>
+                  <a:spcPts val="900"/>
                 </a:lnSpc>
                 <a:spcBef>
                   <a:spcPts val="0"/>
@@ -6965,7 +6965,7 @@
                 </a:spcAft>
               </a:pPr>
               <a:r>
-                <a:rPr sz="800">
+                <a:rPr sz="900">
                   <a:solidFill>
                     <a:srgbClr val="000000">
                       <a:alpha val="100000"/>

</xml_diff>

<commit_message>
Resize Fig.3 and Fig.5 export to 120x100mm
Both are single-panel figures; standardize their export dimensions
to 120x100mm instead of 170x110mm (Fig.3) and 90x100mm (Fig.5).
</commit_message>
<xml_diff>
--- a/figures/Figure_5.pptx
+++ b/figures/Figure_5.pptx
@@ -2250,9 +2250,9 @@
         <p:grpSpPr>
           <a:xfrm>
             <a:off x="914400" y="914400"/>
-            <a:ext cx="3240000" cy="3600000"/>
+            <a:ext cx="4320000" cy="3600000"/>
             <a:chOff x="914400" y="914400"/>
-            <a:chExt cx="3240000" cy="3600000"/>
+            <a:chExt cx="4320000" cy="3600000"/>
           </a:xfrm>
         </p:grpSpPr>
         <p:sp>
@@ -2264,7 +2264,7 @@
           <p:spPr>
             <a:xfrm>
               <a:off x="914400" y="914400"/>
-              <a:ext cx="3240000" cy="3600000"/>
+              <a:ext cx="4320000" cy="3600000"/>
             </a:xfrm>
             <a:prstGeom prst="rect">
               <a:avLst/>
@@ -2299,7 +2299,7 @@
           <p:spPr>
             <a:xfrm>
               <a:off x="914400" y="914400"/>
-              <a:ext cx="3240000" cy="3600000"/>
+              <a:ext cx="4320000" cy="3600000"/>
             </a:xfrm>
             <a:prstGeom prst="rect">
               <a:avLst/>
@@ -2325,7 +2325,7 @@
           <p:spPr>
             <a:xfrm>
               <a:off x="1794699" y="952357"/>
-              <a:ext cx="2309090" cy="2890515"/>
+              <a:ext cx="3389090" cy="2890515"/>
             </a:xfrm>
             <a:prstGeom prst="rect">
               <a:avLst/>
@@ -2350,7 +2350,7 @@
           </p:nvSpPr>
           <p:spPr>
             <a:xfrm>
-              <a:off x="2973116" y="952357"/>
+              <a:off x="3524281" y="952357"/>
               <a:ext cx="0" cy="2890515"/>
             </a:xfrm>
             <a:custGeom>
@@ -2393,7 +2393,7 @@
           </p:nvSpPr>
           <p:spPr>
             <a:xfrm>
-              <a:off x="2831284" y="1047440"/>
+              <a:off x="3316113" y="1047440"/>
               <a:ext cx="0" cy="38033"/>
             </a:xfrm>
             <a:custGeom>
@@ -2433,15 +2433,15 @@
           </p:nvSpPr>
           <p:spPr>
             <a:xfrm>
-              <a:off x="2644323" y="1066456"/>
-              <a:ext cx="186961" cy="0"/>
+              <a:off x="3041706" y="1066456"/>
+              <a:ext cx="274406" cy="0"/>
             </a:xfrm>
             <a:custGeom>
               <a:avLst/>
               <a:pathLst>
-                <a:path w="186961" h="0">
+                <a:path w="274406" h="0">
                   <a:moveTo>
-                    <a:pt x="186961" y="0"/>
+                    <a:pt x="274406" y="0"/>
                   </a:moveTo>
                   <a:lnTo>
                     <a:pt x="0" y="0"/>
@@ -2473,7 +2473,7 @@
           </p:nvSpPr>
           <p:spPr>
             <a:xfrm>
-              <a:off x="2644323" y="1047440"/>
+              <a:off x="3041706" y="1047440"/>
               <a:ext cx="0" cy="38033"/>
             </a:xfrm>
             <a:custGeom>
@@ -2513,7 +2513,7 @@
           </p:nvSpPr>
           <p:spPr>
             <a:xfrm>
-              <a:off x="3907631" y="1237605"/>
+              <a:off x="4895884" y="1237605"/>
               <a:ext cx="0" cy="38033"/>
             </a:xfrm>
             <a:custGeom>
@@ -2553,15 +2553,15 @@
           </p:nvSpPr>
           <p:spPr>
             <a:xfrm>
-              <a:off x="3089101" y="1256622"/>
-              <a:ext cx="818530" cy="0"/>
+              <a:off x="3694514" y="1256622"/>
+              <a:ext cx="1201370" cy="0"/>
             </a:xfrm>
             <a:custGeom>
               <a:avLst/>
               <a:pathLst>
-                <a:path w="818530" h="0">
+                <a:path w="1201370" h="0">
                   <a:moveTo>
-                    <a:pt x="818530" y="0"/>
+                    <a:pt x="1201370" y="0"/>
                   </a:moveTo>
                   <a:lnTo>
                     <a:pt x="0" y="0"/>
@@ -2593,7 +2593,7 @@
           </p:nvSpPr>
           <p:spPr>
             <a:xfrm>
-              <a:off x="3089101" y="1237605"/>
+              <a:off x="3694514" y="1237605"/>
               <a:ext cx="0" cy="38033"/>
             </a:xfrm>
             <a:custGeom>
@@ -2633,7 +2633,7 @@
           </p:nvSpPr>
           <p:spPr>
             <a:xfrm>
-              <a:off x="3971815" y="1427771"/>
+              <a:off x="4990089" y="1427771"/>
               <a:ext cx="0" cy="38033"/>
             </a:xfrm>
             <a:custGeom>
@@ -2673,15 +2673,15 @@
           </p:nvSpPr>
           <p:spPr>
             <a:xfrm>
-              <a:off x="3176936" y="1446787"/>
-              <a:ext cx="794878" cy="0"/>
+              <a:off x="3823432" y="1446787"/>
+              <a:ext cx="1166656" cy="0"/>
             </a:xfrm>
             <a:custGeom>
               <a:avLst/>
               <a:pathLst>
-                <a:path w="794878" h="0">
+                <a:path w="1166656" h="0">
                   <a:moveTo>
-                    <a:pt x="794878" y="0"/>
+                    <a:pt x="1166656" y="0"/>
                   </a:moveTo>
                   <a:lnTo>
                     <a:pt x="0" y="0"/>
@@ -2713,7 +2713,7 @@
           </p:nvSpPr>
           <p:spPr>
             <a:xfrm>
-              <a:off x="3176936" y="1427771"/>
+              <a:off x="3823432" y="1427771"/>
               <a:ext cx="0" cy="38033"/>
             </a:xfrm>
             <a:custGeom>
@@ -2753,7 +2753,7 @@
           </p:nvSpPr>
           <p:spPr>
             <a:xfrm>
-              <a:off x="2952800" y="1617936"/>
+              <a:off x="3494464" y="1617936"/>
               <a:ext cx="0" cy="38033"/>
             </a:xfrm>
             <a:custGeom>
@@ -2793,15 +2793,15 @@
           </p:nvSpPr>
           <p:spPr>
             <a:xfrm>
-              <a:off x="2523172" y="1636953"/>
-              <a:ext cx="429628" cy="0"/>
+              <a:off x="2863892" y="1636953"/>
+              <a:ext cx="630572" cy="0"/>
             </a:xfrm>
             <a:custGeom>
               <a:avLst/>
               <a:pathLst>
-                <a:path w="429628" h="0">
+                <a:path w="630572" h="0">
                   <a:moveTo>
-                    <a:pt x="429628" y="0"/>
+                    <a:pt x="630572" y="0"/>
                   </a:moveTo>
                   <a:lnTo>
                     <a:pt x="0" y="0"/>
@@ -2833,7 +2833,7 @@
           </p:nvSpPr>
           <p:spPr>
             <a:xfrm>
-              <a:off x="2523172" y="1617936"/>
+              <a:off x="2863892" y="1617936"/>
               <a:ext cx="0" cy="38033"/>
             </a:xfrm>
             <a:custGeom>
@@ -2873,7 +2873,7 @@
           </p:nvSpPr>
           <p:spPr>
             <a:xfrm>
-              <a:off x="2667052" y="1808102"/>
+              <a:off x="3075066" y="1808102"/>
               <a:ext cx="0" cy="38033"/>
             </a:xfrm>
             <a:custGeom>
@@ -2913,15 +2913,15 @@
           </p:nvSpPr>
           <p:spPr>
             <a:xfrm>
-              <a:off x="1899657" y="1827119"/>
-              <a:ext cx="767394" cy="0"/>
+              <a:off x="1948748" y="1827119"/>
+              <a:ext cx="1126318" cy="0"/>
             </a:xfrm>
             <a:custGeom>
               <a:avLst/>
               <a:pathLst>
-                <a:path w="767394" h="0">
+                <a:path w="1126318" h="0">
                   <a:moveTo>
-                    <a:pt x="767394" y="0"/>
+                    <a:pt x="1126318" y="0"/>
                   </a:moveTo>
                   <a:lnTo>
                     <a:pt x="0" y="0"/>
@@ -2953,7 +2953,7 @@
           </p:nvSpPr>
           <p:spPr>
             <a:xfrm>
-              <a:off x="1899657" y="1808102"/>
+              <a:off x="1948748" y="1808102"/>
               <a:ext cx="0" cy="38033"/>
             </a:xfrm>
             <a:custGeom>
@@ -2993,7 +2993,7 @@
           </p:nvSpPr>
           <p:spPr>
             <a:xfrm>
-              <a:off x="3656996" y="1998267"/>
+              <a:off x="4528024" y="1998267"/>
               <a:ext cx="0" cy="38033"/>
             </a:xfrm>
             <a:custGeom>
@@ -3033,15 +3033,15 @@
           </p:nvSpPr>
           <p:spPr>
             <a:xfrm>
-              <a:off x="2716067" y="2017284"/>
-              <a:ext cx="940928" cy="0"/>
+              <a:off x="3147007" y="2017284"/>
+              <a:ext cx="1381016" cy="0"/>
             </a:xfrm>
             <a:custGeom>
               <a:avLst/>
               <a:pathLst>
-                <a:path w="940928" h="0">
+                <a:path w="1381016" h="0">
                   <a:moveTo>
-                    <a:pt x="940928" y="0"/>
+                    <a:pt x="1381016" y="0"/>
                   </a:moveTo>
                   <a:lnTo>
                     <a:pt x="0" y="0"/>
@@ -3073,7 +3073,7 @@
           </p:nvSpPr>
           <p:spPr>
             <a:xfrm>
-              <a:off x="2716067" y="1998267"/>
+              <a:off x="3147007" y="1998267"/>
               <a:ext cx="0" cy="38033"/>
             </a:xfrm>
             <a:custGeom>
@@ -3113,7 +3113,7 @@
           </p:nvSpPr>
           <p:spPr>
             <a:xfrm>
-              <a:off x="3187762" y="2188433"/>
+              <a:off x="3839321" y="2188433"/>
               <a:ext cx="0" cy="38033"/>
             </a:xfrm>
             <a:custGeom>
@@ -3153,15 +3153,15 @@
           </p:nvSpPr>
           <p:spPr>
             <a:xfrm>
-              <a:off x="2917728" y="2207450"/>
-              <a:ext cx="270033" cy="0"/>
+              <a:off x="3442988" y="2207450"/>
+              <a:ext cx="396332" cy="0"/>
             </a:xfrm>
             <a:custGeom>
               <a:avLst/>
               <a:pathLst>
-                <a:path w="270033" h="0">
+                <a:path w="396332" h="0">
                   <a:moveTo>
-                    <a:pt x="270033" y="0"/>
+                    <a:pt x="396332" y="0"/>
                   </a:moveTo>
                   <a:lnTo>
                     <a:pt x="0" y="0"/>
@@ -3193,7 +3193,7 @@
           </p:nvSpPr>
           <p:spPr>
             <a:xfrm>
-              <a:off x="2917728" y="2188433"/>
+              <a:off x="3442988" y="2188433"/>
               <a:ext cx="0" cy="38033"/>
             </a:xfrm>
             <a:custGeom>
@@ -3233,7 +3233,7 @@
           </p:nvSpPr>
           <p:spPr>
             <a:xfrm>
-              <a:off x="3998831" y="2378598"/>
+              <a:off x="5029740" y="2378598"/>
               <a:ext cx="0" cy="38033"/>
             </a:xfrm>
             <a:custGeom>
@@ -3273,15 +3273,15 @@
           </p:nvSpPr>
           <p:spPr>
             <a:xfrm>
-              <a:off x="3304990" y="2397615"/>
-              <a:ext cx="693840" cy="0"/>
+              <a:off x="4011378" y="2397615"/>
+              <a:ext cx="1018361" cy="0"/>
             </a:xfrm>
             <a:custGeom>
               <a:avLst/>
               <a:pathLst>
-                <a:path w="693840" h="0">
+                <a:path w="1018361" h="0">
                   <a:moveTo>
-                    <a:pt x="693840" y="0"/>
+                    <a:pt x="1018361" y="0"/>
                   </a:moveTo>
                   <a:lnTo>
                     <a:pt x="0" y="0"/>
@@ -3313,7 +3313,7 @@
           </p:nvSpPr>
           <p:spPr>
             <a:xfrm>
-              <a:off x="3304990" y="2378598"/>
+              <a:off x="4011378" y="2378598"/>
               <a:ext cx="0" cy="38033"/>
             </a:xfrm>
             <a:custGeom>
@@ -3353,7 +3353,7 @@
           </p:nvSpPr>
           <p:spPr>
             <a:xfrm>
-              <a:off x="3069110" y="2568764"/>
+              <a:off x="3665173" y="2568764"/>
               <a:ext cx="0" cy="38033"/>
             </a:xfrm>
             <a:custGeom>
@@ -3393,15 +3393,15 @@
           </p:nvSpPr>
           <p:spPr>
             <a:xfrm>
-              <a:off x="2636683" y="2587781"/>
-              <a:ext cx="432426" cy="0"/>
+              <a:off x="3030493" y="2587781"/>
+              <a:ext cx="634679" cy="0"/>
             </a:xfrm>
             <a:custGeom>
               <a:avLst/>
               <a:pathLst>
-                <a:path w="432426" h="0">
+                <a:path w="634679" h="0">
                   <a:moveTo>
-                    <a:pt x="432426" y="0"/>
+                    <a:pt x="634679" y="0"/>
                   </a:moveTo>
                   <a:lnTo>
                     <a:pt x="0" y="0"/>
@@ -3433,7 +3433,7 @@
           </p:nvSpPr>
           <p:spPr>
             <a:xfrm>
-              <a:off x="2636683" y="2568764"/>
+              <a:off x="3030493" y="2568764"/>
               <a:ext cx="0" cy="38033"/>
             </a:xfrm>
             <a:custGeom>
@@ -3473,7 +3473,7 @@
           </p:nvSpPr>
           <p:spPr>
             <a:xfrm>
-              <a:off x="2916743" y="2758930"/>
+              <a:off x="3441541" y="2758930"/>
               <a:ext cx="0" cy="38033"/>
             </a:xfrm>
             <a:custGeom>
@@ -3513,15 +3513,15 @@
           </p:nvSpPr>
           <p:spPr>
             <a:xfrm>
-              <a:off x="2464600" y="2777946"/>
-              <a:ext cx="452142" cy="0"/>
+              <a:off x="2777925" y="2777946"/>
+              <a:ext cx="663616" cy="0"/>
             </a:xfrm>
             <a:custGeom>
               <a:avLst/>
               <a:pathLst>
-                <a:path w="452142" h="0">
+                <a:path w="663616" h="0">
                   <a:moveTo>
-                    <a:pt x="452142" y="0"/>
+                    <a:pt x="663616" y="0"/>
                   </a:moveTo>
                   <a:lnTo>
                     <a:pt x="0" y="0"/>
@@ -3553,7 +3553,7 @@
           </p:nvSpPr>
           <p:spPr>
             <a:xfrm>
-              <a:off x="2464600" y="2758930"/>
+              <a:off x="2777925" y="2758930"/>
               <a:ext cx="0" cy="38033"/>
             </a:xfrm>
             <a:custGeom>
@@ -3593,7 +3593,7 @@
           </p:nvSpPr>
           <p:spPr>
             <a:xfrm>
-              <a:off x="3609849" y="2949095"/>
+              <a:off x="4458825" y="2949095"/>
               <a:ext cx="0" cy="38033"/>
             </a:xfrm>
             <a:custGeom>
@@ -3633,15 +3633,15 @@
           </p:nvSpPr>
           <p:spPr>
             <a:xfrm>
-              <a:off x="3182897" y="2968112"/>
-              <a:ext cx="426952" cy="0"/>
+              <a:off x="3832181" y="2968112"/>
+              <a:ext cx="626644" cy="0"/>
             </a:xfrm>
             <a:custGeom>
               <a:avLst/>
               <a:pathLst>
-                <a:path w="426952" h="0">
+                <a:path w="626644" h="0">
                   <a:moveTo>
-                    <a:pt x="426952" y="0"/>
+                    <a:pt x="626644" y="0"/>
                   </a:moveTo>
                   <a:lnTo>
                     <a:pt x="0" y="0"/>
@@ -3673,7 +3673,7 @@
           </p:nvSpPr>
           <p:spPr>
             <a:xfrm>
-              <a:off x="3182897" y="2949095"/>
+              <a:off x="3832181" y="2949095"/>
               <a:ext cx="0" cy="38033"/>
             </a:xfrm>
             <a:custGeom>
@@ -3713,7 +3713,7 @@
           </p:nvSpPr>
           <p:spPr>
             <a:xfrm>
-              <a:off x="3504436" y="3139261"/>
+              <a:off x="4304108" y="3139261"/>
               <a:ext cx="0" cy="38033"/>
             </a:xfrm>
             <a:custGeom>
@@ -3753,15 +3753,15 @@
           </p:nvSpPr>
           <p:spPr>
             <a:xfrm>
-              <a:off x="2385901" y="3158277"/>
-              <a:ext cx="1118534" cy="0"/>
+              <a:off x="2662417" y="3158277"/>
+              <a:ext cx="1641691" cy="0"/>
             </a:xfrm>
             <a:custGeom>
               <a:avLst/>
               <a:pathLst>
-                <a:path w="1118534" h="0">
+                <a:path w="1641691" h="0">
                   <a:moveTo>
-                    <a:pt x="1118534" y="0"/>
+                    <a:pt x="1641691" y="0"/>
                   </a:moveTo>
                   <a:lnTo>
                     <a:pt x="0" y="0"/>
@@ -3793,7 +3793,7 @@
           </p:nvSpPr>
           <p:spPr>
             <a:xfrm>
-              <a:off x="2385901" y="3139261"/>
+              <a:off x="2662417" y="3139261"/>
               <a:ext cx="0" cy="38033"/>
             </a:xfrm>
             <a:custGeom>
@@ -3833,7 +3833,7 @@
           </p:nvSpPr>
           <p:spPr>
             <a:xfrm>
-              <a:off x="3262126" y="3329426"/>
+              <a:off x="3948466" y="3329426"/>
               <a:ext cx="0" cy="38033"/>
             </a:xfrm>
             <a:custGeom>
@@ -3873,15 +3873,15 @@
           </p:nvSpPr>
           <p:spPr>
             <a:xfrm>
-              <a:off x="2193223" y="3348443"/>
-              <a:ext cx="1068902" cy="0"/>
+              <a:off x="2379620" y="3348443"/>
+              <a:ext cx="1568846" cy="0"/>
             </a:xfrm>
             <a:custGeom>
               <a:avLst/>
               <a:pathLst>
-                <a:path w="1068902" h="0">
+                <a:path w="1568846" h="0">
                   <a:moveTo>
-                    <a:pt x="1068902" y="0"/>
+                    <a:pt x="1568846" y="0"/>
                   </a:moveTo>
                   <a:lnTo>
                     <a:pt x="0" y="0"/>
@@ -3913,7 +3913,7 @@
           </p:nvSpPr>
           <p:spPr>
             <a:xfrm>
-              <a:off x="2193223" y="3329426"/>
+              <a:off x="2379620" y="3329426"/>
               <a:ext cx="0" cy="38033"/>
             </a:xfrm>
             <a:custGeom>
@@ -3953,7 +3953,7 @@
           </p:nvSpPr>
           <p:spPr>
             <a:xfrm>
-              <a:off x="3434657" y="3519592"/>
+              <a:off x="4201693" y="3519592"/>
               <a:ext cx="0" cy="38033"/>
             </a:xfrm>
             <a:custGeom>
@@ -3993,15 +3993,15 @@
           </p:nvSpPr>
           <p:spPr>
             <a:xfrm>
-              <a:off x="2279201" y="3538608"/>
-              <a:ext cx="1155455" cy="0"/>
+              <a:off x="2505811" y="3538608"/>
+              <a:ext cx="1695881" cy="0"/>
             </a:xfrm>
             <a:custGeom>
               <a:avLst/>
               <a:pathLst>
-                <a:path w="1155455" h="0">
+                <a:path w="1695881" h="0">
                   <a:moveTo>
-                    <a:pt x="1155455" y="0"/>
+                    <a:pt x="1695881" y="0"/>
                   </a:moveTo>
                   <a:lnTo>
                     <a:pt x="0" y="0"/>
@@ -4033,7 +4033,7 @@
           </p:nvSpPr>
           <p:spPr>
             <a:xfrm>
-              <a:off x="2279201" y="3519592"/>
+              <a:off x="2505811" y="3519592"/>
               <a:ext cx="0" cy="38033"/>
             </a:xfrm>
             <a:custGeom>
@@ -4073,7 +4073,7 @@
           </p:nvSpPr>
           <p:spPr>
             <a:xfrm>
-              <a:off x="2775593" y="3709757"/>
+              <a:off x="3234373" y="3709757"/>
               <a:ext cx="0" cy="38033"/>
             </a:xfrm>
             <a:custGeom>
@@ -4113,15 +4113,15 @@
           </p:nvSpPr>
           <p:spPr>
             <a:xfrm>
-              <a:off x="2341655" y="3728774"/>
-              <a:ext cx="433937" cy="0"/>
+              <a:off x="2597476" y="3728774"/>
+              <a:ext cx="636896" cy="0"/>
             </a:xfrm>
             <a:custGeom>
               <a:avLst/>
               <a:pathLst>
-                <a:path w="433937" h="0">
+                <a:path w="636896" h="0">
                   <a:moveTo>
-                    <a:pt x="433937" y="0"/>
+                    <a:pt x="636896" y="0"/>
                   </a:moveTo>
                   <a:lnTo>
                     <a:pt x="0" y="0"/>
@@ -4153,7 +4153,7 @@
           </p:nvSpPr>
           <p:spPr>
             <a:xfrm>
-              <a:off x="2341655" y="3709757"/>
+              <a:off x="2597476" y="3709757"/>
               <a:ext cx="0" cy="38033"/>
             </a:xfrm>
             <a:custGeom>
@@ -4193,7 +4193,7 @@
           </p:nvSpPr>
           <p:spPr>
             <a:xfrm>
-              <a:off x="2686352" y="1015005"/>
+              <a:off x="3127457" y="1015005"/>
               <a:ext cx="102903" cy="102903"/>
             </a:xfrm>
             <a:prstGeom prst="ellipse">
@@ -4228,7 +4228,7 @@
           </p:nvSpPr>
           <p:spPr>
             <a:xfrm>
-              <a:off x="3446914" y="1205170"/>
+              <a:off x="4243747" y="1205170"/>
               <a:ext cx="102903" cy="102903"/>
             </a:xfrm>
             <a:prstGeom prst="ellipse">
@@ -4263,7 +4263,7 @@
           </p:nvSpPr>
           <p:spPr>
             <a:xfrm>
-              <a:off x="3522924" y="1395336"/>
+              <a:off x="4355308" y="1395336"/>
               <a:ext cx="102903" cy="102903"/>
             </a:xfrm>
             <a:prstGeom prst="ellipse">
@@ -4298,7 +4298,7 @@
           </p:nvSpPr>
           <p:spPr>
             <a:xfrm>
-              <a:off x="2686535" y="1585501"/>
+              <a:off x="3127726" y="1585501"/>
               <a:ext cx="102903" cy="102903"/>
             </a:xfrm>
             <a:prstGeom prst="ellipse">
@@ -4333,7 +4333,7 @@
           </p:nvSpPr>
           <p:spPr>
             <a:xfrm>
-              <a:off x="2231903" y="1775667"/>
+              <a:off x="2460456" y="1775667"/>
               <a:ext cx="102903" cy="102903"/>
             </a:xfrm>
             <a:prstGeom prst="ellipse">
@@ -4368,7 +4368,7 @@
           </p:nvSpPr>
           <p:spPr>
             <a:xfrm>
-              <a:off x="3135080" y="1965832"/>
+              <a:off x="3786063" y="1965832"/>
               <a:ext cx="102903" cy="102903"/>
             </a:xfrm>
             <a:prstGeom prst="ellipse">
@@ -4403,7 +4403,7 @@
           </p:nvSpPr>
           <p:spPr>
             <a:xfrm>
-              <a:off x="3001293" y="2155998"/>
+              <a:off x="3589703" y="2155998"/>
               <a:ext cx="102903" cy="102903"/>
             </a:xfrm>
             <a:prstGeom prst="ellipse">
@@ -4438,7 +4438,7 @@
           </p:nvSpPr>
           <p:spPr>
             <a:xfrm>
-              <a:off x="3600458" y="2346163"/>
+              <a:off x="4469107" y="2346163"/>
               <a:ext cx="102903" cy="102903"/>
             </a:xfrm>
             <a:prstGeom prst="ellipse">
@@ -4473,7 +4473,7 @@
           </p:nvSpPr>
           <p:spPr>
             <a:xfrm>
-              <a:off x="2801444" y="2536329"/>
+              <a:off x="3296381" y="2536329"/>
               <a:ext cx="102903" cy="102903"/>
             </a:xfrm>
             <a:prstGeom prst="ellipse">
@@ -4508,7 +4508,7 @@
           </p:nvSpPr>
           <p:spPr>
             <a:xfrm>
-              <a:off x="2639220" y="2726494"/>
+              <a:off x="3058281" y="2726494"/>
               <a:ext cx="102903" cy="102903"/>
             </a:xfrm>
             <a:prstGeom prst="ellipse">
@@ -4543,7 +4543,7 @@
           </p:nvSpPr>
           <p:spPr>
             <a:xfrm>
-              <a:off x="3344921" y="2916660"/>
+              <a:off x="4094051" y="2916660"/>
               <a:ext cx="102903" cy="102903"/>
             </a:xfrm>
             <a:prstGeom prst="ellipse">
@@ -4578,7 +4578,7 @@
           </p:nvSpPr>
           <p:spPr>
             <a:xfrm>
-              <a:off x="2893717" y="3106825"/>
+              <a:off x="3431811" y="3106825"/>
               <a:ext cx="102903" cy="102903"/>
             </a:xfrm>
             <a:prstGeom prst="ellipse">
@@ -4613,7 +4613,7 @@
           </p:nvSpPr>
           <p:spPr>
             <a:xfrm>
-              <a:off x="2676223" y="3296991"/>
+              <a:off x="3112591" y="3296991"/>
               <a:ext cx="102903" cy="102903"/>
             </a:xfrm>
             <a:prstGeom prst="ellipse">
@@ -4648,7 +4648,7 @@
           </p:nvSpPr>
           <p:spPr>
             <a:xfrm>
-              <a:off x="2805477" y="3487156"/>
+              <a:off x="3302300" y="3487156"/>
               <a:ext cx="102903" cy="102903"/>
             </a:xfrm>
             <a:prstGeom prst="ellipse">
@@ -4683,7 +4683,7 @@
           </p:nvSpPr>
           <p:spPr>
             <a:xfrm>
-              <a:off x="2507172" y="3677322"/>
+              <a:off x="2864473" y="3677322"/>
               <a:ext cx="102903" cy="102903"/>
             </a:xfrm>
             <a:prstGeom prst="ellipse">
@@ -4719,7 +4719,7 @@
           <p:spPr>
             <a:xfrm>
               <a:off x="1794699" y="952357"/>
-              <a:ext cx="2309090" cy="2890515"/>
+              <a:ext cx="3389090" cy="2890515"/>
             </a:xfrm>
             <a:prstGeom prst="rect">
               <a:avLst/>
@@ -6070,17 +6070,17 @@
           <p:spPr>
             <a:xfrm>
               <a:off x="1794699" y="3842873"/>
-              <a:ext cx="2309090" cy="0"/>
+              <a:ext cx="3389090" cy="0"/>
             </a:xfrm>
             <a:custGeom>
               <a:avLst/>
               <a:pathLst>
-                <a:path w="2309090" h="0">
+                <a:path w="3389090" h="0">
                   <a:moveTo>
                     <a:pt x="0" y="0"/>
                   </a:moveTo>
                   <a:lnTo>
-                    <a:pt x="2309090" y="0"/>
+                    <a:pt x="3389090" y="0"/>
                   </a:lnTo>
                 </a:path>
               </a:pathLst>
@@ -6109,7 +6109,7 @@
           </p:nvSpPr>
           <p:spPr>
             <a:xfrm>
-              <a:off x="1921965" y="3842873"/>
+              <a:off x="1981489" y="3842873"/>
               <a:ext cx="0" cy="31631"/>
             </a:xfrm>
             <a:custGeom>
@@ -6149,7 +6149,7 @@
           </p:nvSpPr>
           <p:spPr>
             <a:xfrm>
-              <a:off x="2447540" y="3842873"/>
+              <a:off x="2752885" y="3842873"/>
               <a:ext cx="0" cy="31631"/>
             </a:xfrm>
             <a:custGeom>
@@ -6189,7 +6189,7 @@
           </p:nvSpPr>
           <p:spPr>
             <a:xfrm>
-              <a:off x="2973116" y="3842873"/>
+              <a:off x="3524281" y="3842873"/>
               <a:ext cx="0" cy="31631"/>
             </a:xfrm>
             <a:custGeom>
@@ -6229,7 +6229,7 @@
           </p:nvSpPr>
           <p:spPr>
             <a:xfrm>
-              <a:off x="3498691" y="3842873"/>
+              <a:off x="4295677" y="3842873"/>
               <a:ext cx="0" cy="31631"/>
             </a:xfrm>
             <a:custGeom>
@@ -6269,7 +6269,7 @@
           </p:nvSpPr>
           <p:spPr>
             <a:xfrm>
-              <a:off x="4024267" y="3842873"/>
+              <a:off x="5067073" y="3842873"/>
               <a:ext cx="0" cy="31631"/>
             </a:xfrm>
             <a:custGeom>
@@ -6309,7 +6309,7 @@
           </p:nvSpPr>
           <p:spPr>
             <a:xfrm>
-              <a:off x="1791754" y="3899809"/>
+              <a:off x="1851278" y="3899809"/>
               <a:ext cx="260421" cy="82021"/>
             </a:xfrm>
             <a:prstGeom prst="rect">
@@ -6355,7 +6355,7 @@
           </p:nvSpPr>
           <p:spPr>
             <a:xfrm>
-              <a:off x="2317330" y="3899809"/>
+              <a:off x="2622674" y="3899809"/>
               <a:ext cx="260421" cy="82021"/>
             </a:xfrm>
             <a:prstGeom prst="rect">
@@ -6401,7 +6401,7 @@
           </p:nvSpPr>
           <p:spPr>
             <a:xfrm>
-              <a:off x="2861925" y="3899809"/>
+              <a:off x="3413090" y="3899809"/>
               <a:ext cx="222382" cy="82021"/>
             </a:xfrm>
             <a:prstGeom prst="rect">
@@ -6447,7 +6447,7 @@
           </p:nvSpPr>
           <p:spPr>
             <a:xfrm>
-              <a:off x="3387500" y="3899809"/>
+              <a:off x="4184486" y="3899809"/>
               <a:ext cx="222382" cy="82021"/>
             </a:xfrm>
             <a:prstGeom prst="rect">
@@ -6493,7 +6493,7 @@
           </p:nvSpPr>
           <p:spPr>
             <a:xfrm>
-              <a:off x="3913076" y="3899809"/>
+              <a:off x="4955882" y="3899809"/>
               <a:ext cx="222382" cy="82021"/>
             </a:xfrm>
             <a:prstGeom prst="rect">
@@ -6539,7 +6539,7 @@
           </p:nvSpPr>
           <p:spPr>
             <a:xfrm>
-              <a:off x="1873864" y="4075879"/>
+              <a:off x="2413864" y="4075879"/>
               <a:ext cx="2150760" cy="100218"/>
             </a:xfrm>
             <a:prstGeom prst="rect">
@@ -6631,8 +6631,8 @@
           </p:nvSpPr>
           <p:spPr>
             <a:xfrm>
-              <a:off x="1556366" y="4296442"/>
-              <a:ext cx="2598033" cy="180000"/>
+              <a:off x="2096366" y="4296442"/>
+              <a:ext cx="2785756" cy="180000"/>
             </a:xfrm>
             <a:prstGeom prst="rect">
               <a:avLst/>
@@ -6657,7 +6657,7 @@
           </p:nvSpPr>
           <p:spPr>
             <a:xfrm>
-              <a:off x="1556366" y="4340722"/>
+              <a:off x="2096366" y="4340722"/>
               <a:ext cx="825703" cy="91440"/>
             </a:xfrm>
             <a:prstGeom prst="rect">
@@ -6703,7 +6703,7 @@
           </p:nvSpPr>
           <p:spPr>
             <a:xfrm>
-              <a:off x="2445332" y="4296442"/>
+              <a:off x="2985332" y="4296442"/>
               <a:ext cx="179999" cy="180000"/>
             </a:xfrm>
             <a:prstGeom prst="rect">
@@ -6729,7 +6729,7 @@
           </p:nvSpPr>
           <p:spPr>
             <a:xfrm>
-              <a:off x="2463332" y="4386442"/>
+              <a:off x="3003332" y="4386442"/>
               <a:ext cx="144000" cy="0"/>
             </a:xfrm>
             <a:custGeom>
@@ -6769,7 +6769,7 @@
           </p:nvSpPr>
           <p:spPr>
             <a:xfrm>
-              <a:off x="2483880" y="4334990"/>
+              <a:off x="3023880" y="4334990"/>
               <a:ext cx="102903" cy="102903"/>
             </a:xfrm>
             <a:prstGeom prst="ellipse">
@@ -6799,7 +6799,7 @@
           </p:nvSpPr>
           <p:spPr>
             <a:xfrm>
-              <a:off x="3431713" y="4296442"/>
+              <a:off x="3971713" y="4296442"/>
               <a:ext cx="179999" cy="180000"/>
             </a:xfrm>
             <a:prstGeom prst="rect">
@@ -6825,18 +6825,18 @@
           </p:nvSpPr>
           <p:spPr>
             <a:xfrm>
-              <a:off x="3449713" y="4386442"/>
-              <a:ext cx="144000" cy="0"/>
+              <a:off x="3989713" y="4386442"/>
+              <a:ext cx="143999" cy="0"/>
             </a:xfrm>
             <a:custGeom>
               <a:avLst/>
               <a:pathLst>
-                <a:path w="144000" h="0">
+                <a:path w="143999" h="0">
                   <a:moveTo>
                     <a:pt x="0" y="0"/>
                   </a:moveTo>
                   <a:lnTo>
-                    <a:pt x="144000" y="0"/>
+                    <a:pt x="143999" y="0"/>
                   </a:lnTo>
                 </a:path>
               </a:pathLst>
@@ -6865,7 +6865,7 @@
           </p:nvSpPr>
           <p:spPr>
             <a:xfrm>
-              <a:off x="3470262" y="4334990"/>
+              <a:off x="4010262" y="4334990"/>
               <a:ext cx="102903" cy="102903"/>
             </a:xfrm>
             <a:prstGeom prst="ellipse">
@@ -6895,7 +6895,7 @@
           </p:nvSpPr>
           <p:spPr>
             <a:xfrm>
-              <a:off x="2688594" y="4345431"/>
+              <a:off x="3228594" y="4345431"/>
               <a:ext cx="679856" cy="82021"/>
             </a:xfrm>
             <a:prstGeom prst="rect">
@@ -6941,7 +6941,7 @@
           </p:nvSpPr>
           <p:spPr>
             <a:xfrm>
-              <a:off x="3674976" y="4345431"/>
+              <a:off x="4214976" y="4345431"/>
               <a:ext cx="667146" cy="82021"/>
             </a:xfrm>
             <a:prstGeom prst="rect">

</xml_diff>